<commit_message>
feat(slide L7): +2 slide — prompting AI + EU AI Act
Aggiunte 2 slide alla L7 per coprire argomenti residui della dispensa:

Slide 11 (nuova) — Prompting per la sicurezza
  Two-col layout con confronto:
  - Prompt VAGO ('scrivi endpoint login') → produce versione media,
    spesso vulnerabile (SHA-256, no rate limit, cookie senza HttpOnly,
    f-string in SQL)
  - Prompt SPECIFICO con requisiti di sicurezza espliciti → produce
    codice molto più vicino al giusto

Slide 13 (nuova) — EU AI Act (Reg. UE 2024/1689)
  Cornice normativa:
  - Vigore agosto 2024, piena applicazione agosto 2026
  - Approccio risk-based a 4 categorie
  - Implicazioni per chi usa/integra AI nei prodotti
  - Sanzioni fino a 35M€ o 7% fatturato

Slide takeaway aggiornata con due punti nuovi.

Totale L7: 14 → 16 slide. Totale corso: 117 → 119 slide.

Coerenza slide ↔ dispensa: 100% su tutti gli argomenti tecnici e normativi.

Co-Authored-By: Claude Opus 4.7 <noreply@anthropic.com>
</commit_message>
<xml_diff>
--- a/docx/slide/L7_documentazione_ai.pptx
+++ b/docx/slide/L7_documentazione_ai.pptx
@@ -19,6 +19,8 @@
     <p:sldId id="267" r:id="rId18"/>
     <p:sldId id="268" r:id="rId19"/>
     <p:sldId id="269" r:id="rId20"/>
+    <p:sldId id="270" r:id="rId21"/>
+    <p:sldId id="271" r:id="rId22"/>
   </p:sldIdLst>
   <p:sldSz cx="12191695" cy="6858000" type="screen4x3"/>
   <p:notesSz cx="6858000" cy="9144000"/>
@@ -4106,7 +4108,7 @@
                 </a:solidFill>
                 <a:latin typeface="Calibri"/>
               </a:rPr>
-              <a:t>L7  ·  10/14</a:t>
+              <a:t>L7  ·  10/16</a:t>
             </a:r>
           </a:p>
         </p:txBody>
@@ -4202,21 +4204,148 @@
                 </a:solidFill>
                 <a:latin typeface="Calibri"/>
               </a:rPr>
-              <a:t>🛑  Quando NON usare l'IA</a:t>
-            </a:r>
-          </a:p>
-        </p:txBody>
-      </p:sp>
-      <p:sp>
-        <p:nvSpPr>
-          <p:cNvPr id="4" name="TextBox 3"/>
+              <a:t>Prompting per la sicurezza: vago vs specifico</a:t>
+            </a:r>
+          </a:p>
+        </p:txBody>
+      </p:sp>
+      <p:sp>
+        <p:nvSpPr>
+          <p:cNvPr id="4" name="Rounded Rectangle 3"/>
+          <p:cNvSpPr/>
+          <p:nvPr/>
+        </p:nvSpPr>
+        <p:spPr>
+          <a:xfrm>
+            <a:off x="457200" y="1051560"/>
+            <a:ext cx="5486400" cy="640080"/>
+          </a:xfrm>
+          <a:prstGeom prst="roundRect">
+            <a:avLst>
+              <a:gd name="adj" fmla="val 8000"/>
+            </a:avLst>
+          </a:prstGeom>
+          <a:solidFill>
+            <a:srgbClr val="E63946"/>
+          </a:solidFill>
+          <a:ln>
+            <a:noFill/>
+          </a:ln>
+        </p:spPr>
+        <p:style>
+          <a:lnRef idx="1">
+            <a:schemeClr val="accent1"/>
+          </a:lnRef>
+          <a:fillRef idx="3">
+            <a:schemeClr val="accent1"/>
+          </a:fillRef>
+          <a:effectRef idx="2">
+            <a:schemeClr val="accent1"/>
+          </a:effectRef>
+          <a:fontRef idx="minor">
+            <a:schemeClr val="lt1"/>
+          </a:fontRef>
+        </p:style>
+        <p:txBody>
+          <a:bodyPr rtlCol="0" anchor="ctr"/>
+          <a:lstStyle/>
+          <a:p>
+            <a:pPr algn="ctr"/>
+          </a:p>
+        </p:txBody>
+      </p:sp>
+      <p:sp>
+        <p:nvSpPr>
+          <p:cNvPr id="5" name="TextBox 4"/>
           <p:cNvSpPr txBox="1"/>
           <p:nvPr/>
         </p:nvSpPr>
         <p:spPr>
           <a:xfrm>
-            <a:off x="640080" y="1097280"/>
-            <a:ext cx="10972800" cy="5029200"/>
+            <a:off x="457200" y="1051560"/>
+            <a:ext cx="5486400" cy="640080"/>
+          </a:xfrm>
+          <a:prstGeom prst="rect">
+            <a:avLst/>
+          </a:prstGeom>
+          <a:noFill/>
+        </p:spPr>
+        <p:txBody>
+          <a:bodyPr wrap="square" lIns="45720" rIns="45720" tIns="18288" bIns="18288" anchor="ctr">
+            <a:spAutoFit/>
+          </a:bodyPr>
+          <a:lstStyle/>
+          <a:p>
+            <a:pPr algn="ctr"/>
+            <a:r>
+              <a:rPr sz="1800" b="1" i="0">
+                <a:solidFill>
+                  <a:srgbClr val="FFFFFF"/>
+                </a:solidFill>
+                <a:latin typeface="Calibri"/>
+              </a:rPr>
+              <a:t>❌ Prompt VAGO (rischioso)</a:t>
+            </a:r>
+          </a:p>
+        </p:txBody>
+      </p:sp>
+      <p:sp>
+        <p:nvSpPr>
+          <p:cNvPr id="6" name="Rounded Rectangle 5"/>
+          <p:cNvSpPr/>
+          <p:nvPr/>
+        </p:nvSpPr>
+        <p:spPr>
+          <a:xfrm>
+            <a:off x="457200" y="1737360"/>
+            <a:ext cx="5486400" cy="4572000"/>
+          </a:xfrm>
+          <a:prstGeom prst="roundRect">
+            <a:avLst>
+              <a:gd name="adj" fmla="val 8000"/>
+            </a:avLst>
+          </a:prstGeom>
+          <a:solidFill>
+            <a:srgbClr val="FBFBFD"/>
+          </a:solidFill>
+          <a:ln w="25400">
+            <a:solidFill>
+              <a:srgbClr val="E63946"/>
+            </a:solidFill>
+          </a:ln>
+        </p:spPr>
+        <p:style>
+          <a:lnRef idx="1">
+            <a:schemeClr val="accent1"/>
+          </a:lnRef>
+          <a:fillRef idx="3">
+            <a:schemeClr val="accent1"/>
+          </a:fillRef>
+          <a:effectRef idx="2">
+            <a:schemeClr val="accent1"/>
+          </a:effectRef>
+          <a:fontRef idx="minor">
+            <a:schemeClr val="lt1"/>
+          </a:fontRef>
+        </p:style>
+        <p:txBody>
+          <a:bodyPr rtlCol="0" anchor="ctr"/>
+          <a:lstStyle/>
+          <a:p>
+            <a:pPr algn="ctr"/>
+          </a:p>
+        </p:txBody>
+      </p:sp>
+      <p:sp>
+        <p:nvSpPr>
+          <p:cNvPr id="7" name="TextBox 6"/>
+          <p:cNvSpPr txBox="1"/>
+          <p:nvPr/>
+        </p:nvSpPr>
+        <p:spPr>
+          <a:xfrm>
+            <a:off x="640080" y="1874519"/>
+            <a:ext cx="5120640" cy="4572000"/>
           </a:xfrm>
           <a:prstGeom prst="rect">
             <a:avLst/>
@@ -4238,22 +4367,22 @@
               </a:spcAft>
             </a:pPr>
             <a:r>
-              <a:rPr sz="2000" b="1">
-                <a:solidFill>
-                  <a:srgbClr val="00A0B0"/>
+              <a:rPr sz="1500" b="1">
+                <a:solidFill>
+                  <a:srgbClr val="E63946"/>
                 </a:solidFill>
                 <a:latin typeface="Calibri"/>
               </a:rPr>
               <a:t>▸  </a:t>
             </a:r>
             <a:r>
-              <a:rPr sz="2000">
+              <a:rPr sz="1500">
                 <a:solidFill>
                   <a:srgbClr val="1A1A2E"/>
                 </a:solidFill>
                 <a:latin typeface="Calibri"/>
               </a:rPr>
-              <a:t>Crittografia 'fatta in casa' (usa librerie standard)</a:t>
+              <a:t>'Scrivi un endpoint Flask</a:t>
             </a:r>
           </a:p>
           <a:p>
@@ -4266,22 +4395,22 @@
               </a:spcAft>
             </a:pPr>
             <a:r>
-              <a:rPr sz="2000" b="1">
-                <a:solidFill>
-                  <a:srgbClr val="00A0B0"/>
+              <a:rPr sz="1500" b="1">
+                <a:solidFill>
+                  <a:srgbClr val="E63946"/>
                 </a:solidFill>
                 <a:latin typeface="Calibri"/>
               </a:rPr>
               <a:t>▸  </a:t>
             </a:r>
             <a:r>
-              <a:rPr sz="2000">
+              <a:rPr sz="1500">
                 <a:solidFill>
                   <a:srgbClr val="1A1A2E"/>
                 </a:solidFill>
                 <a:latin typeface="Calibri"/>
               </a:rPr>
-              <a:t>Codice di sicurezza critico (authn/authz)</a:t>
+              <a:t>per login'</a:t>
             </a:r>
           </a:p>
           <a:p>
@@ -4294,22 +4423,22 @@
               </a:spcAft>
             </a:pPr>
             <a:r>
-              <a:rPr sz="2000" b="1">
-                <a:solidFill>
-                  <a:srgbClr val="00A0B0"/>
+              <a:rPr sz="1500" b="1">
+                <a:solidFill>
+                  <a:srgbClr val="E63946"/>
                 </a:solidFill>
                 <a:latin typeface="Calibri"/>
               </a:rPr>
               <a:t>▸  </a:t>
             </a:r>
             <a:r>
-              <a:rPr sz="2000">
+              <a:rPr sz="1500">
                 <a:solidFill>
                   <a:srgbClr val="1A1A2E"/>
                 </a:solidFill>
                 <a:latin typeface="Calibri"/>
               </a:rPr>
-              <a:t>Compliance e legale (privacy policy, validation IBAN/CF)</a:t>
+              <a:t/>
             </a:r>
           </a:p>
           <a:p>
@@ -4322,22 +4451,22 @@
               </a:spcAft>
             </a:pPr>
             <a:r>
-              <a:rPr sz="2000" b="1">
-                <a:solidFill>
-                  <a:srgbClr val="00A0B0"/>
+              <a:rPr sz="1500" b="1">
+                <a:solidFill>
+                  <a:srgbClr val="E63946"/>
                 </a:solidFill>
                 <a:latin typeface="Calibri"/>
               </a:rPr>
               <a:t>▸  </a:t>
             </a:r>
             <a:r>
-              <a:rPr sz="2000">
+              <a:rPr sz="1500">
                 <a:solidFill>
                   <a:srgbClr val="1A1A2E"/>
                 </a:solidFill>
                 <a:latin typeface="Calibri"/>
               </a:rPr>
-              <a:t>Quando NON sai validare (impara prima)</a:t>
+              <a:t>L'IA produce la versione</a:t>
             </a:r>
           </a:p>
           <a:p>
@@ -4350,22 +4479,22 @@
               </a:spcAft>
             </a:pPr>
             <a:r>
-              <a:rPr sz="2000" b="1">
-                <a:solidFill>
-                  <a:srgbClr val="00A0B0"/>
+              <a:rPr sz="1500" b="1">
+                <a:solidFill>
+                  <a:srgbClr val="E63946"/>
                 </a:solidFill>
                 <a:latin typeface="Calibri"/>
               </a:rPr>
               <a:t>▸  </a:t>
             </a:r>
             <a:r>
-              <a:rPr sz="2000">
+              <a:rPr sz="1500">
                 <a:solidFill>
                   <a:srgbClr val="1A1A2E"/>
                 </a:solidFill>
                 <a:latin typeface="Calibri"/>
               </a:rPr>
-              <a:t/>
+              <a:t>MEDIA: spesso vulnerabile</a:t>
             </a:r>
           </a:p>
           <a:p>
@@ -4378,22 +4507,22 @@
               </a:spcAft>
             </a:pPr>
             <a:r>
-              <a:rPr sz="2000" b="1">
-                <a:solidFill>
-                  <a:srgbClr val="00A0B0"/>
+              <a:rPr sz="1500" b="1">
+                <a:solidFill>
+                  <a:srgbClr val="E63946"/>
                 </a:solidFill>
                 <a:latin typeface="Calibri"/>
               </a:rPr>
               <a:t>▸  </a:t>
             </a:r>
             <a:r>
-              <a:rPr sz="2000">
+              <a:rPr sz="1500">
                 <a:solidFill>
                   <a:srgbClr val="1A1A2E"/>
                 </a:solidFill>
                 <a:latin typeface="Calibri"/>
               </a:rPr>
-              <a:t>Caso reale: Samsung 2023</a:t>
+              <a:t/>
             </a:r>
           </a:p>
           <a:p>
@@ -4406,22 +4535,22 @@
               </a:spcAft>
             </a:pPr>
             <a:r>
-              <a:rPr sz="2000" b="1">
-                <a:solidFill>
-                  <a:srgbClr val="00A0B0"/>
+              <a:rPr sz="1500" b="1">
+                <a:solidFill>
+                  <a:srgbClr val="E63946"/>
                 </a:solidFill>
                 <a:latin typeface="Calibri"/>
               </a:rPr>
               <a:t>▸  </a:t>
             </a:r>
             <a:r>
-              <a:rPr sz="2000">
+              <a:rPr sz="1500">
                 <a:solidFill>
                   <a:srgbClr val="1A1A2E"/>
                 </a:solidFill>
                 <a:latin typeface="Calibri"/>
               </a:rPr>
-              <a:t>Dipendenti incollarono codice proprietario in ChatGPT</a:t>
+              <a:t>Risultato tipico:</a:t>
             </a:r>
           </a:p>
           <a:p>
@@ -4434,22 +4563,22 @@
               </a:spcAft>
             </a:pPr>
             <a:r>
-              <a:rPr sz="2000" b="1">
-                <a:solidFill>
-                  <a:srgbClr val="00A0B0"/>
+              <a:rPr sz="1500" b="1">
+                <a:solidFill>
+                  <a:srgbClr val="E63946"/>
                 </a:solidFill>
                 <a:latin typeface="Calibri"/>
               </a:rPr>
               <a:t>▸  </a:t>
             </a:r>
             <a:r>
-              <a:rPr sz="2000">
+              <a:rPr sz="1500">
                 <a:solidFill>
                   <a:srgbClr val="1A1A2E"/>
                 </a:solidFill>
                 <a:latin typeface="Calibri"/>
               </a:rPr>
-              <a:t>OpenAI lo usò per training → codice leakato indirettamente</a:t>
+              <a:t>  password con SHA-256</a:t>
             </a:r>
           </a:p>
           <a:p>
@@ -4462,29 +4591,543 @@
               </a:spcAft>
             </a:pPr>
             <a:r>
-              <a:rPr sz="2000" b="1">
-                <a:solidFill>
-                  <a:srgbClr val="00A0B0"/>
+              <a:rPr sz="1500" b="1">
+                <a:solidFill>
+                  <a:srgbClr val="E63946"/>
                 </a:solidFill>
                 <a:latin typeface="Calibri"/>
               </a:rPr>
               <a:t>▸  </a:t>
             </a:r>
             <a:r>
-              <a:rPr sz="2000">
+              <a:rPr sz="1500">
                 <a:solidFill>
                   <a:srgbClr val="1A1A2E"/>
                 </a:solidFill>
                 <a:latin typeface="Calibri"/>
               </a:rPr>
-              <a:t>Samsung dovette vietare ChatGPT internamente</a:t>
+              <a:t>  nessun rate limit</a:t>
+            </a:r>
+          </a:p>
+          <a:p>
+            <a:pPr>
+              <a:lnSpc>
+                <a:spcPct val="150000"/>
+              </a:lnSpc>
+              <a:spcAft>
+                <a:spcPts val="400"/>
+              </a:spcAft>
+            </a:pPr>
+            <a:r>
+              <a:rPr sz="1500" b="1">
+                <a:solidFill>
+                  <a:srgbClr val="E63946"/>
+                </a:solidFill>
+                <a:latin typeface="Calibri"/>
+              </a:rPr>
+              <a:t>▸  </a:t>
+            </a:r>
+            <a:r>
+              <a:rPr sz="1500">
+                <a:solidFill>
+                  <a:srgbClr val="1A1A2E"/>
+                </a:solidFill>
+                <a:latin typeface="Calibri"/>
+              </a:rPr>
+              <a:t>  cookie senza HttpOnly</a:t>
+            </a:r>
+          </a:p>
+          <a:p>
+            <a:pPr>
+              <a:lnSpc>
+                <a:spcPct val="150000"/>
+              </a:lnSpc>
+              <a:spcAft>
+                <a:spcPts val="400"/>
+              </a:spcAft>
+            </a:pPr>
+            <a:r>
+              <a:rPr sz="1500" b="1">
+                <a:solidFill>
+                  <a:srgbClr val="E63946"/>
+                </a:solidFill>
+                <a:latin typeface="Calibri"/>
+              </a:rPr>
+              <a:t>▸  </a:t>
+            </a:r>
+            <a:r>
+              <a:rPr sz="1500">
+                <a:solidFill>
+                  <a:srgbClr val="1A1A2E"/>
+                </a:solidFill>
+                <a:latin typeface="Calibri"/>
+              </a:rPr>
+              <a:t>  query con f-string</a:t>
+            </a:r>
+          </a:p>
+        </p:txBody>
+      </p:sp>
+      <p:sp>
+        <p:nvSpPr>
+          <p:cNvPr id="8" name="Rounded Rectangle 7"/>
+          <p:cNvSpPr/>
+          <p:nvPr/>
+        </p:nvSpPr>
+        <p:spPr>
+          <a:xfrm>
+            <a:off x="6217920" y="1051560"/>
+            <a:ext cx="5486400" cy="640080"/>
+          </a:xfrm>
+          <a:prstGeom prst="roundRect">
+            <a:avLst>
+              <a:gd name="adj" fmla="val 8000"/>
+            </a:avLst>
+          </a:prstGeom>
+          <a:solidFill>
+            <a:srgbClr val="06A77D"/>
+          </a:solidFill>
+          <a:ln>
+            <a:noFill/>
+          </a:ln>
+        </p:spPr>
+        <p:style>
+          <a:lnRef idx="1">
+            <a:schemeClr val="accent1"/>
+          </a:lnRef>
+          <a:fillRef idx="3">
+            <a:schemeClr val="accent1"/>
+          </a:fillRef>
+          <a:effectRef idx="2">
+            <a:schemeClr val="accent1"/>
+          </a:effectRef>
+          <a:fontRef idx="minor">
+            <a:schemeClr val="lt1"/>
+          </a:fontRef>
+        </p:style>
+        <p:txBody>
+          <a:bodyPr rtlCol="0" anchor="ctr"/>
+          <a:lstStyle/>
+          <a:p>
+            <a:pPr algn="ctr"/>
+          </a:p>
+        </p:txBody>
+      </p:sp>
+      <p:sp>
+        <p:nvSpPr>
+          <p:cNvPr id="9" name="TextBox 8"/>
+          <p:cNvSpPr txBox="1"/>
+          <p:nvPr/>
+        </p:nvSpPr>
+        <p:spPr>
+          <a:xfrm>
+            <a:off x="6217920" y="1051560"/>
+            <a:ext cx="5486400" cy="640080"/>
+          </a:xfrm>
+          <a:prstGeom prst="rect">
+            <a:avLst/>
+          </a:prstGeom>
+          <a:noFill/>
+        </p:spPr>
+        <p:txBody>
+          <a:bodyPr wrap="square" lIns="45720" rIns="45720" tIns="18288" bIns="18288" anchor="ctr">
+            <a:spAutoFit/>
+          </a:bodyPr>
+          <a:lstStyle/>
+          <a:p>
+            <a:pPr algn="ctr"/>
+            <a:r>
+              <a:rPr sz="1800" b="1" i="0">
+                <a:solidFill>
+                  <a:srgbClr val="FFFFFF"/>
+                </a:solidFill>
+                <a:latin typeface="Calibri"/>
+              </a:rPr>
+              <a:t>✅ Prompt SPECIFICO (sicuro)</a:t>
+            </a:r>
+          </a:p>
+        </p:txBody>
+      </p:sp>
+      <p:sp>
+        <p:nvSpPr>
+          <p:cNvPr id="10" name="Rounded Rectangle 9"/>
+          <p:cNvSpPr/>
+          <p:nvPr/>
+        </p:nvSpPr>
+        <p:spPr>
+          <a:xfrm>
+            <a:off x="6217920" y="1737360"/>
+            <a:ext cx="5486400" cy="4572000"/>
+          </a:xfrm>
+          <a:prstGeom prst="roundRect">
+            <a:avLst>
+              <a:gd name="adj" fmla="val 8000"/>
+            </a:avLst>
+          </a:prstGeom>
+          <a:solidFill>
+            <a:srgbClr val="FBFBFD"/>
+          </a:solidFill>
+          <a:ln w="25400">
+            <a:solidFill>
+              <a:srgbClr val="06A77D"/>
+            </a:solidFill>
+          </a:ln>
+        </p:spPr>
+        <p:style>
+          <a:lnRef idx="1">
+            <a:schemeClr val="accent1"/>
+          </a:lnRef>
+          <a:fillRef idx="3">
+            <a:schemeClr val="accent1"/>
+          </a:fillRef>
+          <a:effectRef idx="2">
+            <a:schemeClr val="accent1"/>
+          </a:effectRef>
+          <a:fontRef idx="minor">
+            <a:schemeClr val="lt1"/>
+          </a:fontRef>
+        </p:style>
+        <p:txBody>
+          <a:bodyPr rtlCol="0" anchor="ctr"/>
+          <a:lstStyle/>
+          <a:p>
+            <a:pPr algn="ctr"/>
+          </a:p>
+        </p:txBody>
+      </p:sp>
+      <p:sp>
+        <p:nvSpPr>
+          <p:cNvPr id="11" name="TextBox 10"/>
+          <p:cNvSpPr txBox="1"/>
+          <p:nvPr/>
+        </p:nvSpPr>
+        <p:spPr>
+          <a:xfrm>
+            <a:off x="6400800" y="1874519"/>
+            <a:ext cx="5120640" cy="4572000"/>
+          </a:xfrm>
+          <a:prstGeom prst="rect">
+            <a:avLst/>
+          </a:prstGeom>
+          <a:noFill/>
+        </p:spPr>
+        <p:txBody>
+          <a:bodyPr wrap="square">
+            <a:spAutoFit/>
+          </a:bodyPr>
+          <a:lstStyle/>
+          <a:p>
+            <a:pPr>
+              <a:lnSpc>
+                <a:spcPct val="150000"/>
+              </a:lnSpc>
+              <a:spcAft>
+                <a:spcPts val="400"/>
+              </a:spcAft>
+            </a:pPr>
+            <a:r>
+              <a:rPr sz="1500" b="1">
+                <a:solidFill>
+                  <a:srgbClr val="06A77D"/>
+                </a:solidFill>
+                <a:latin typeface="Calibri"/>
+              </a:rPr>
+              <a:t>▸  </a:t>
+            </a:r>
+            <a:r>
+              <a:rPr sz="1500">
+                <a:solidFill>
+                  <a:srgbClr val="1A1A2E"/>
+                </a:solidFill>
+                <a:latin typeface="Calibri"/>
+              </a:rPr>
+              <a:t>'Scrivi /login POST che:</a:t>
+            </a:r>
+          </a:p>
+          <a:p>
+            <a:pPr>
+              <a:lnSpc>
+                <a:spcPct val="150000"/>
+              </a:lnSpc>
+              <a:spcAft>
+                <a:spcPts val="400"/>
+              </a:spcAft>
+            </a:pPr>
+            <a:r>
+              <a:rPr sz="1500" b="1">
+                <a:solidFill>
+                  <a:srgbClr val="06A77D"/>
+                </a:solidFill>
+                <a:latin typeface="Calibri"/>
+              </a:rPr>
+              <a:t>▸  </a:t>
+            </a:r>
+            <a:r>
+              <a:rPr sz="1500">
+                <a:solidFill>
+                  <a:srgbClr val="1A1A2E"/>
+                </a:solidFill>
+                <a:latin typeface="Calibri"/>
+              </a:rPr>
+              <a:t>- bcrypt per password</a:t>
+            </a:r>
+          </a:p>
+          <a:p>
+            <a:pPr>
+              <a:lnSpc>
+                <a:spcPct val="150000"/>
+              </a:lnSpc>
+              <a:spcAft>
+                <a:spcPts val="400"/>
+              </a:spcAft>
+            </a:pPr>
+            <a:r>
+              <a:rPr sz="1500" b="1">
+                <a:solidFill>
+                  <a:srgbClr val="06A77D"/>
+                </a:solidFill>
+                <a:latin typeface="Calibri"/>
+              </a:rPr>
+              <a:t>▸  </a:t>
+            </a:r>
+            <a:r>
+              <a:rPr sz="1500">
+                <a:solidFill>
+                  <a:srgbClr val="1A1A2E"/>
+                </a:solidFill>
+                <a:latin typeface="Calibri"/>
+              </a:rPr>
+              <a:t>- risposta uniforme</a:t>
+            </a:r>
+          </a:p>
+          <a:p>
+            <a:pPr>
+              <a:lnSpc>
+                <a:spcPct val="150000"/>
+              </a:lnSpc>
+              <a:spcAft>
+                <a:spcPts val="400"/>
+              </a:spcAft>
+            </a:pPr>
+            <a:r>
+              <a:rPr sz="1500" b="1">
+                <a:solidFill>
+                  <a:srgbClr val="06A77D"/>
+                </a:solidFill>
+                <a:latin typeface="Calibri"/>
+              </a:rPr>
+              <a:t>▸  </a:t>
+            </a:r>
+            <a:r>
+              <a:rPr sz="1500">
+                <a:solidFill>
+                  <a:srgbClr val="1A1A2E"/>
+                </a:solidFill>
+                <a:latin typeface="Calibri"/>
+              </a:rPr>
+              <a:t>  (no user enumeration)</a:t>
+            </a:r>
+          </a:p>
+          <a:p>
+            <a:pPr>
+              <a:lnSpc>
+                <a:spcPct val="150000"/>
+              </a:lnSpc>
+              <a:spcAft>
+                <a:spcPts val="400"/>
+              </a:spcAft>
+            </a:pPr>
+            <a:r>
+              <a:rPr sz="1500" b="1">
+                <a:solidFill>
+                  <a:srgbClr val="06A77D"/>
+                </a:solidFill>
+                <a:latin typeface="Calibri"/>
+              </a:rPr>
+              <a:t>▸  </a:t>
+            </a:r>
+            <a:r>
+              <a:rPr sz="1500">
+                <a:solidFill>
+                  <a:srgbClr val="1A1A2E"/>
+                </a:solidFill>
+                <a:latin typeface="Calibri"/>
+              </a:rPr>
+              <a:t>- rate limit 5/min</a:t>
+            </a:r>
+          </a:p>
+          <a:p>
+            <a:pPr>
+              <a:lnSpc>
+                <a:spcPct val="150000"/>
+              </a:lnSpc>
+              <a:spcAft>
+                <a:spcPts val="400"/>
+              </a:spcAft>
+            </a:pPr>
+            <a:r>
+              <a:rPr sz="1500" b="1">
+                <a:solidFill>
+                  <a:srgbClr val="06A77D"/>
+                </a:solidFill>
+                <a:latin typeface="Calibri"/>
+              </a:rPr>
+              <a:t>▸  </a:t>
+            </a:r>
+            <a:r>
+              <a:rPr sz="1500">
+                <a:solidFill>
+                  <a:srgbClr val="1A1A2E"/>
+                </a:solidFill>
+                <a:latin typeface="Calibri"/>
+              </a:rPr>
+              <a:t>- cookie Secure+HttpOnly</a:t>
+            </a:r>
+          </a:p>
+          <a:p>
+            <a:pPr>
+              <a:lnSpc>
+                <a:spcPct val="150000"/>
+              </a:lnSpc>
+              <a:spcAft>
+                <a:spcPts val="400"/>
+              </a:spcAft>
+            </a:pPr>
+            <a:r>
+              <a:rPr sz="1500" b="1">
+                <a:solidFill>
+                  <a:srgbClr val="06A77D"/>
+                </a:solidFill>
+                <a:latin typeface="Calibri"/>
+              </a:rPr>
+              <a:t>▸  </a:t>
+            </a:r>
+            <a:r>
+              <a:rPr sz="1500">
+                <a:solidFill>
+                  <a:srgbClr val="1A1A2E"/>
+                </a:solidFill>
+                <a:latin typeface="Calibri"/>
+              </a:rPr>
+              <a:t>  +SameSite=Lax</a:t>
+            </a:r>
+          </a:p>
+          <a:p>
+            <a:pPr>
+              <a:lnSpc>
+                <a:spcPct val="150000"/>
+              </a:lnSpc>
+              <a:spcAft>
+                <a:spcPts val="400"/>
+              </a:spcAft>
+            </a:pPr>
+            <a:r>
+              <a:rPr sz="1500" b="1">
+                <a:solidFill>
+                  <a:srgbClr val="06A77D"/>
+                </a:solidFill>
+                <a:latin typeface="Calibri"/>
+              </a:rPr>
+              <a:t>▸  </a:t>
+            </a:r>
+            <a:r>
+              <a:rPr sz="1500">
+                <a:solidFill>
+                  <a:srgbClr val="1A1A2E"/>
+                </a:solidFill>
+                <a:latin typeface="Calibri"/>
+              </a:rPr>
+              <a:t>- logga eventi auth in</a:t>
+            </a:r>
+          </a:p>
+          <a:p>
+            <a:pPr>
+              <a:lnSpc>
+                <a:spcPct val="150000"/>
+              </a:lnSpc>
+              <a:spcAft>
+                <a:spcPts val="400"/>
+              </a:spcAft>
+            </a:pPr>
+            <a:r>
+              <a:rPr sz="1500" b="1">
+                <a:solidFill>
+                  <a:srgbClr val="06A77D"/>
+                </a:solidFill>
+                <a:latin typeface="Calibri"/>
+              </a:rPr>
+              <a:t>▸  </a:t>
+            </a:r>
+            <a:r>
+              <a:rPr sz="1500">
+                <a:solidFill>
+                  <a:srgbClr val="1A1A2E"/>
+                </a:solidFill>
+                <a:latin typeface="Calibri"/>
+              </a:rPr>
+              <a:t>  formato JSON ECS'</a:t>
+            </a:r>
+          </a:p>
+          <a:p>
+            <a:pPr>
+              <a:lnSpc>
+                <a:spcPct val="150000"/>
+              </a:lnSpc>
+              <a:spcAft>
+                <a:spcPts val="400"/>
+              </a:spcAft>
+            </a:pPr>
+            <a:r>
+              <a:rPr sz="1500" b="1">
+                <a:solidFill>
+                  <a:srgbClr val="06A77D"/>
+                </a:solidFill>
+                <a:latin typeface="Calibri"/>
+              </a:rPr>
+              <a:t>▸  </a:t>
+            </a:r>
+            <a:r>
+              <a:rPr sz="1500">
+                <a:solidFill>
+                  <a:srgbClr val="1A1A2E"/>
+                </a:solidFill>
+                <a:latin typeface="Calibri"/>
+              </a:rPr>
+              <a:t/>
+            </a:r>
+          </a:p>
+          <a:p>
+            <a:pPr>
+              <a:lnSpc>
+                <a:spcPct val="150000"/>
+              </a:lnSpc>
+              <a:spcAft>
+                <a:spcPts val="400"/>
+              </a:spcAft>
+            </a:pPr>
+            <a:r>
+              <a:rPr sz="1500" b="1">
+                <a:solidFill>
+                  <a:srgbClr val="06A77D"/>
+                </a:solidFill>
+                <a:latin typeface="Calibri"/>
+              </a:rPr>
+              <a:t>▸  </a:t>
+            </a:r>
+            <a:r>
+              <a:rPr sz="1500">
+                <a:solidFill>
+                  <a:srgbClr val="1A1A2E"/>
+                </a:solidFill>
+                <a:latin typeface="Calibri"/>
+              </a:rPr>
+              <a:t>Risultato vicino a giusto</a:t>
             </a:r>
           </a:p>
         </p:txBody>
       </p:sp>
       <p:cxnSp>
         <p:nvCxnSpPr>
-          <p:cNvPr id="5" name="Connector 4"/>
+          <p:cNvPr id="12" name="Connector 11"/>
           <p:cNvCxnSpPr/>
           <p:nvPr/>
         </p:nvCxnSpPr>
@@ -4519,7 +5162,7 @@
       </p:cxnSp>
       <p:sp>
         <p:nvSpPr>
-          <p:cNvPr id="6" name="TextBox 5"/>
+          <p:cNvPr id="13" name="TextBox 12"/>
           <p:cNvSpPr txBox="1"/>
           <p:nvPr/>
         </p:nvSpPr>
@@ -4554,7 +5197,7 @@
       </p:sp>
       <p:sp>
         <p:nvSpPr>
-          <p:cNvPr id="7" name="TextBox 6"/>
+          <p:cNvPr id="14" name="TextBox 13"/>
           <p:cNvSpPr txBox="1"/>
           <p:nvPr/>
         </p:nvSpPr>
@@ -4582,7 +5225,7 @@
                 </a:solidFill>
                 <a:latin typeface="Calibri"/>
               </a:rPr>
-              <a:t>L7  ·  11/14</a:t>
+              <a:t>L7  ·  11/16</a:t>
             </a:r>
           </a:p>
         </p:txBody>
@@ -4678,64 +5321,21 @@
                 </a:solidFill>
                 <a:latin typeface="Calibri"/>
               </a:rPr>
-              <a:t>📌  Cosa portare a casa</a:t>
-            </a:r>
-          </a:p>
-        </p:txBody>
-      </p:sp>
-      <p:sp>
-        <p:nvSpPr>
-          <p:cNvPr id="4" name="Oval 3"/>
-          <p:cNvSpPr/>
-          <p:nvPr/>
-        </p:nvSpPr>
-        <p:spPr>
-          <a:xfrm>
-            <a:off x="914400" y="1440180"/>
-            <a:ext cx="777240" cy="777240"/>
-          </a:xfrm>
-          <a:prstGeom prst="ellipse">
-            <a:avLst/>
-          </a:prstGeom>
-          <a:solidFill>
-            <a:srgbClr val="00A0B0"/>
-          </a:solidFill>
-          <a:ln>
-            <a:noFill/>
-          </a:ln>
-        </p:spPr>
-        <p:style>
-          <a:lnRef idx="1">
-            <a:schemeClr val="accent1"/>
-          </a:lnRef>
-          <a:fillRef idx="3">
-            <a:schemeClr val="accent1"/>
-          </a:fillRef>
-          <a:effectRef idx="2">
-            <a:schemeClr val="accent1"/>
-          </a:effectRef>
-          <a:fontRef idx="minor">
-            <a:schemeClr val="lt1"/>
-          </a:fontRef>
-        </p:style>
-        <p:txBody>
-          <a:bodyPr rtlCol="0" anchor="ctr"/>
-          <a:lstStyle/>
-          <a:p>
-            <a:pPr algn="ctr"/>
-          </a:p>
-        </p:txBody>
-      </p:sp>
-      <p:sp>
-        <p:nvSpPr>
-          <p:cNvPr id="5" name="TextBox 4"/>
+              <a:t>🛑  Quando NON usare l'IA</a:t>
+            </a:r>
+          </a:p>
+        </p:txBody>
+      </p:sp>
+      <p:sp>
+        <p:nvSpPr>
+          <p:cNvPr id="4" name="TextBox 3"/>
           <p:cNvSpPr txBox="1"/>
           <p:nvPr/>
         </p:nvSpPr>
         <p:spPr>
           <a:xfrm>
-            <a:off x="914400" y="1440180"/>
-            <a:ext cx="777240" cy="777240"/>
+            <a:off x="640080" y="1097280"/>
+            <a:ext cx="10972800" cy="5029200"/>
           </a:xfrm>
           <a:prstGeom prst="rect">
             <a:avLst/>
@@ -4743,749 +5343,267 @@
           <a:noFill/>
         </p:spPr>
         <p:txBody>
-          <a:bodyPr wrap="square" lIns="45720" rIns="45720" tIns="18288" bIns="18288" anchor="ctr">
+          <a:bodyPr wrap="square">
             <a:spAutoFit/>
           </a:bodyPr>
           <a:lstStyle/>
           <a:p>
-            <a:pPr algn="ctr"/>
-            <a:r>
-              <a:rPr sz="2800" b="1" i="0">
-                <a:solidFill>
-                  <a:srgbClr val="FFFFFF"/>
-                </a:solidFill>
-                <a:latin typeface="Calibri"/>
-              </a:rPr>
-              <a:t>1</a:t>
-            </a:r>
-          </a:p>
-        </p:txBody>
-      </p:sp>
-      <p:sp>
-        <p:nvSpPr>
-          <p:cNvPr id="6" name="Rounded Rectangle 5"/>
-          <p:cNvSpPr/>
-          <p:nvPr/>
-        </p:nvSpPr>
-        <p:spPr>
-          <a:xfrm>
-            <a:off x="2011680" y="1440180"/>
-            <a:ext cx="9144000" cy="777240"/>
-          </a:xfrm>
-          <a:prstGeom prst="roundRect">
-            <a:avLst>
-              <a:gd name="adj" fmla="val 8000"/>
-            </a:avLst>
-          </a:prstGeom>
-          <a:solidFill>
-            <a:srgbClr val="FBFBFD"/>
-          </a:solidFill>
-          <a:ln w="19050">
-            <a:solidFill>
-              <a:srgbClr val="00A0B0"/>
-            </a:solidFill>
-          </a:ln>
-        </p:spPr>
-        <p:style>
-          <a:lnRef idx="1">
-            <a:schemeClr val="accent1"/>
-          </a:lnRef>
-          <a:fillRef idx="3">
-            <a:schemeClr val="accent1"/>
-          </a:fillRef>
-          <a:effectRef idx="2">
-            <a:schemeClr val="accent1"/>
-          </a:effectRef>
-          <a:fontRef idx="minor">
-            <a:schemeClr val="lt1"/>
-          </a:fontRef>
-        </p:style>
-        <p:txBody>
-          <a:bodyPr rtlCol="0" anchor="ctr"/>
-          <a:lstStyle/>
-          <a:p>
-            <a:pPr algn="ctr"/>
-          </a:p>
-        </p:txBody>
-      </p:sp>
-      <p:sp>
-        <p:nvSpPr>
-          <p:cNvPr id="7" name="TextBox 6"/>
-          <p:cNvSpPr txBox="1"/>
-          <p:nvPr/>
-        </p:nvSpPr>
-        <p:spPr>
-          <a:xfrm>
-            <a:off x="2286000" y="1440180"/>
-            <a:ext cx="8686800" cy="777240"/>
-          </a:xfrm>
-          <a:prstGeom prst="rect">
-            <a:avLst/>
-          </a:prstGeom>
-          <a:noFill/>
-        </p:spPr>
-        <p:txBody>
-          <a:bodyPr wrap="square" lIns="45720" rIns="45720" tIns="18288" bIns="18288" anchor="ctr">
-            <a:spAutoFit/>
-          </a:bodyPr>
-          <a:lstStyle/>
-          <a:p>
-            <a:pPr algn="l"/>
-            <a:r>
-              <a:rPr sz="1800" b="0" i="0">
+            <a:pPr>
+              <a:lnSpc>
+                <a:spcPct val="150000"/>
+              </a:lnSpc>
+              <a:spcAft>
+                <a:spcPts val="400"/>
+              </a:spcAft>
+            </a:pPr>
+            <a:r>
+              <a:rPr sz="2000" b="1">
+                <a:solidFill>
+                  <a:srgbClr val="00A0B0"/>
+                </a:solidFill>
+                <a:latin typeface="Calibri"/>
+              </a:rPr>
+              <a:t>▸  </a:t>
+            </a:r>
+            <a:r>
+              <a:rPr sz="2000">
                 <a:solidFill>
                   <a:srgbClr val="1A1A2E"/>
                 </a:solidFill>
                 <a:latin typeface="Calibri"/>
               </a:rPr>
-              <a:t>Documentare la sicurezza è un REQUISITO legale e operativo</a:t>
-            </a:r>
-          </a:p>
-        </p:txBody>
-      </p:sp>
-      <p:sp>
-        <p:nvSpPr>
-          <p:cNvPr id="8" name="Oval 7"/>
-          <p:cNvSpPr/>
-          <p:nvPr/>
-        </p:nvSpPr>
-        <p:spPr>
-          <a:xfrm>
-            <a:off x="914400" y="2354580"/>
-            <a:ext cx="777240" cy="777240"/>
-          </a:xfrm>
-          <a:prstGeom prst="ellipse">
-            <a:avLst/>
-          </a:prstGeom>
-          <a:solidFill>
-            <a:srgbClr val="00A0B0"/>
-          </a:solidFill>
-          <a:ln>
-            <a:noFill/>
-          </a:ln>
-        </p:spPr>
-        <p:style>
-          <a:lnRef idx="1">
-            <a:schemeClr val="accent1"/>
-          </a:lnRef>
-          <a:fillRef idx="3">
-            <a:schemeClr val="accent1"/>
-          </a:fillRef>
-          <a:effectRef idx="2">
-            <a:schemeClr val="accent1"/>
-          </a:effectRef>
-          <a:fontRef idx="minor">
-            <a:schemeClr val="lt1"/>
-          </a:fontRef>
-        </p:style>
-        <p:txBody>
-          <a:bodyPr rtlCol="0" anchor="ctr"/>
-          <a:lstStyle/>
-          <a:p>
-            <a:pPr algn="ctr"/>
-          </a:p>
-        </p:txBody>
-      </p:sp>
-      <p:sp>
-        <p:nvSpPr>
-          <p:cNvPr id="9" name="TextBox 8"/>
-          <p:cNvSpPr txBox="1"/>
-          <p:nvPr/>
-        </p:nvSpPr>
-        <p:spPr>
-          <a:xfrm>
-            <a:off x="914400" y="2354580"/>
-            <a:ext cx="777240" cy="777240"/>
-          </a:xfrm>
-          <a:prstGeom prst="rect">
-            <a:avLst/>
-          </a:prstGeom>
-          <a:noFill/>
-        </p:spPr>
-        <p:txBody>
-          <a:bodyPr wrap="square" lIns="45720" rIns="45720" tIns="18288" bIns="18288" anchor="ctr">
-            <a:spAutoFit/>
-          </a:bodyPr>
-          <a:lstStyle/>
-          <a:p>
-            <a:pPr algn="ctr"/>
-            <a:r>
-              <a:rPr sz="2800" b="1" i="0">
-                <a:solidFill>
-                  <a:srgbClr val="FFFFFF"/>
-                </a:solidFill>
-                <a:latin typeface="Calibri"/>
-              </a:rPr>
-              <a:t>2</a:t>
-            </a:r>
-          </a:p>
-        </p:txBody>
-      </p:sp>
-      <p:sp>
-        <p:nvSpPr>
-          <p:cNvPr id="10" name="Rounded Rectangle 9"/>
-          <p:cNvSpPr/>
-          <p:nvPr/>
-        </p:nvSpPr>
-        <p:spPr>
-          <a:xfrm>
-            <a:off x="2011680" y="2354580"/>
-            <a:ext cx="9144000" cy="777240"/>
-          </a:xfrm>
-          <a:prstGeom prst="roundRect">
-            <a:avLst>
-              <a:gd name="adj" fmla="val 8000"/>
-            </a:avLst>
-          </a:prstGeom>
-          <a:solidFill>
-            <a:srgbClr val="FBFBFD"/>
-          </a:solidFill>
-          <a:ln w="19050">
-            <a:solidFill>
-              <a:srgbClr val="00A0B0"/>
-            </a:solidFill>
-          </a:ln>
-        </p:spPr>
-        <p:style>
-          <a:lnRef idx="1">
-            <a:schemeClr val="accent1"/>
-          </a:lnRef>
-          <a:fillRef idx="3">
-            <a:schemeClr val="accent1"/>
-          </a:fillRef>
-          <a:effectRef idx="2">
-            <a:schemeClr val="accent1"/>
-          </a:effectRef>
-          <a:fontRef idx="minor">
-            <a:schemeClr val="lt1"/>
-          </a:fontRef>
-        </p:style>
-        <p:txBody>
-          <a:bodyPr rtlCol="0" anchor="ctr"/>
-          <a:lstStyle/>
-          <a:p>
-            <a:pPr algn="ctr"/>
-          </a:p>
-        </p:txBody>
-      </p:sp>
-      <p:sp>
-        <p:nvSpPr>
-          <p:cNvPr id="11" name="TextBox 10"/>
-          <p:cNvSpPr txBox="1"/>
-          <p:nvPr/>
-        </p:nvSpPr>
-        <p:spPr>
-          <a:xfrm>
-            <a:off x="2286000" y="2354580"/>
-            <a:ext cx="8686800" cy="777240"/>
-          </a:xfrm>
-          <a:prstGeom prst="rect">
-            <a:avLst/>
-          </a:prstGeom>
-          <a:noFill/>
-        </p:spPr>
-        <p:txBody>
-          <a:bodyPr wrap="square" lIns="45720" rIns="45720" tIns="18288" bIns="18288" anchor="ctr">
-            <a:spAutoFit/>
-          </a:bodyPr>
-          <a:lstStyle/>
-          <a:p>
-            <a:pPr algn="l"/>
-            <a:r>
-              <a:rPr sz="1800" b="0" i="0">
+              <a:t>Crittografia 'fatta in casa' (usa librerie standard)</a:t>
+            </a:r>
+          </a:p>
+          <a:p>
+            <a:pPr>
+              <a:lnSpc>
+                <a:spcPct val="150000"/>
+              </a:lnSpc>
+              <a:spcAft>
+                <a:spcPts val="400"/>
+              </a:spcAft>
+            </a:pPr>
+            <a:r>
+              <a:rPr sz="2000" b="1">
+                <a:solidFill>
+                  <a:srgbClr val="00A0B0"/>
+                </a:solidFill>
+                <a:latin typeface="Calibri"/>
+              </a:rPr>
+              <a:t>▸  </a:t>
+            </a:r>
+            <a:r>
+              <a:rPr sz="2000">
                 <a:solidFill>
                   <a:srgbClr val="1A1A2E"/>
                 </a:solidFill>
                 <a:latin typeface="Calibri"/>
               </a:rPr>
-              <a:t>SECURITY.md versionato con il codice</a:t>
-            </a:r>
-          </a:p>
-        </p:txBody>
-      </p:sp>
-      <p:sp>
-        <p:nvSpPr>
-          <p:cNvPr id="12" name="Oval 11"/>
-          <p:cNvSpPr/>
-          <p:nvPr/>
-        </p:nvSpPr>
-        <p:spPr>
-          <a:xfrm>
-            <a:off x="914400" y="3268980"/>
-            <a:ext cx="777240" cy="777240"/>
-          </a:xfrm>
-          <a:prstGeom prst="ellipse">
-            <a:avLst/>
-          </a:prstGeom>
-          <a:solidFill>
-            <a:srgbClr val="00A0B0"/>
-          </a:solidFill>
-          <a:ln>
-            <a:noFill/>
-          </a:ln>
-        </p:spPr>
-        <p:style>
-          <a:lnRef idx="1">
-            <a:schemeClr val="accent1"/>
-          </a:lnRef>
-          <a:fillRef idx="3">
-            <a:schemeClr val="accent1"/>
-          </a:fillRef>
-          <a:effectRef idx="2">
-            <a:schemeClr val="accent1"/>
-          </a:effectRef>
-          <a:fontRef idx="minor">
-            <a:schemeClr val="lt1"/>
-          </a:fontRef>
-        </p:style>
-        <p:txBody>
-          <a:bodyPr rtlCol="0" anchor="ctr"/>
-          <a:lstStyle/>
-          <a:p>
-            <a:pPr algn="ctr"/>
-          </a:p>
-        </p:txBody>
-      </p:sp>
-      <p:sp>
-        <p:nvSpPr>
-          <p:cNvPr id="13" name="TextBox 12"/>
-          <p:cNvSpPr txBox="1"/>
-          <p:nvPr/>
-        </p:nvSpPr>
-        <p:spPr>
-          <a:xfrm>
-            <a:off x="914400" y="3268980"/>
-            <a:ext cx="777240" cy="777240"/>
-          </a:xfrm>
-          <a:prstGeom prst="rect">
-            <a:avLst/>
-          </a:prstGeom>
-          <a:noFill/>
-        </p:spPr>
-        <p:txBody>
-          <a:bodyPr wrap="square" lIns="45720" rIns="45720" tIns="18288" bIns="18288" anchor="ctr">
-            <a:spAutoFit/>
-          </a:bodyPr>
-          <a:lstStyle/>
-          <a:p>
-            <a:pPr algn="ctr"/>
-            <a:r>
-              <a:rPr sz="2800" b="1" i="0">
-                <a:solidFill>
-                  <a:srgbClr val="FFFFFF"/>
-                </a:solidFill>
-                <a:latin typeface="Calibri"/>
-              </a:rPr>
-              <a:t>3</a:t>
-            </a:r>
-          </a:p>
-        </p:txBody>
-      </p:sp>
-      <p:sp>
-        <p:nvSpPr>
-          <p:cNvPr id="14" name="Rounded Rectangle 13"/>
-          <p:cNvSpPr/>
-          <p:nvPr/>
-        </p:nvSpPr>
-        <p:spPr>
-          <a:xfrm>
-            <a:off x="2011680" y="3268980"/>
-            <a:ext cx="9144000" cy="777240"/>
-          </a:xfrm>
-          <a:prstGeom prst="roundRect">
-            <a:avLst>
-              <a:gd name="adj" fmla="val 8000"/>
-            </a:avLst>
-          </a:prstGeom>
-          <a:solidFill>
-            <a:srgbClr val="FBFBFD"/>
-          </a:solidFill>
-          <a:ln w="19050">
-            <a:solidFill>
-              <a:srgbClr val="00A0B0"/>
-            </a:solidFill>
-          </a:ln>
-        </p:spPr>
-        <p:style>
-          <a:lnRef idx="1">
-            <a:schemeClr val="accent1"/>
-          </a:lnRef>
-          <a:fillRef idx="3">
-            <a:schemeClr val="accent1"/>
-          </a:fillRef>
-          <a:effectRef idx="2">
-            <a:schemeClr val="accent1"/>
-          </a:effectRef>
-          <a:fontRef idx="minor">
-            <a:schemeClr val="lt1"/>
-          </a:fontRef>
-        </p:style>
-        <p:txBody>
-          <a:bodyPr rtlCol="0" anchor="ctr"/>
-          <a:lstStyle/>
-          <a:p>
-            <a:pPr algn="ctr"/>
-          </a:p>
-        </p:txBody>
-      </p:sp>
-      <p:sp>
-        <p:nvSpPr>
-          <p:cNvPr id="15" name="TextBox 14"/>
-          <p:cNvSpPr txBox="1"/>
-          <p:nvPr/>
-        </p:nvSpPr>
-        <p:spPr>
-          <a:xfrm>
-            <a:off x="2286000" y="3268980"/>
-            <a:ext cx="8686800" cy="777240"/>
-          </a:xfrm>
-          <a:prstGeom prst="rect">
-            <a:avLst/>
-          </a:prstGeom>
-          <a:noFill/>
-        </p:spPr>
-        <p:txBody>
-          <a:bodyPr wrap="square" lIns="45720" rIns="45720" tIns="18288" bIns="18288" anchor="ctr">
-            <a:spAutoFit/>
-          </a:bodyPr>
-          <a:lstStyle/>
-          <a:p>
-            <a:pPr algn="l"/>
-            <a:r>
-              <a:rPr sz="1800" b="0" i="0">
+              <a:t>Codice di sicurezza critico (authn/authz)</a:t>
+            </a:r>
+          </a:p>
+          <a:p>
+            <a:pPr>
+              <a:lnSpc>
+                <a:spcPct val="150000"/>
+              </a:lnSpc>
+              <a:spcAft>
+                <a:spcPts val="400"/>
+              </a:spcAft>
+            </a:pPr>
+            <a:r>
+              <a:rPr sz="2000" b="1">
+                <a:solidFill>
+                  <a:srgbClr val="00A0B0"/>
+                </a:solidFill>
+                <a:latin typeface="Calibri"/>
+              </a:rPr>
+              <a:t>▸  </a:t>
+            </a:r>
+            <a:r>
+              <a:rPr sz="2000">
                 <a:solidFill>
                   <a:srgbClr val="1A1A2E"/>
                 </a:solidFill>
                 <a:latin typeface="Calibri"/>
               </a:rPr>
-              <a:t>L'IA non sa di sicurezza: validare ogni suggerimento</a:t>
-            </a:r>
-          </a:p>
-        </p:txBody>
-      </p:sp>
-      <p:sp>
-        <p:nvSpPr>
-          <p:cNvPr id="16" name="Oval 15"/>
-          <p:cNvSpPr/>
-          <p:nvPr/>
-        </p:nvSpPr>
-        <p:spPr>
-          <a:xfrm>
-            <a:off x="914400" y="4183380"/>
-            <a:ext cx="777240" cy="777240"/>
-          </a:xfrm>
-          <a:prstGeom prst="ellipse">
-            <a:avLst/>
-          </a:prstGeom>
-          <a:solidFill>
-            <a:srgbClr val="00A0B0"/>
-          </a:solidFill>
-          <a:ln>
-            <a:noFill/>
-          </a:ln>
-        </p:spPr>
-        <p:style>
-          <a:lnRef idx="1">
-            <a:schemeClr val="accent1"/>
-          </a:lnRef>
-          <a:fillRef idx="3">
-            <a:schemeClr val="accent1"/>
-          </a:fillRef>
-          <a:effectRef idx="2">
-            <a:schemeClr val="accent1"/>
-          </a:effectRef>
-          <a:fontRef idx="minor">
-            <a:schemeClr val="lt1"/>
-          </a:fontRef>
-        </p:style>
-        <p:txBody>
-          <a:bodyPr rtlCol="0" anchor="ctr"/>
-          <a:lstStyle/>
-          <a:p>
-            <a:pPr algn="ctr"/>
-          </a:p>
-        </p:txBody>
-      </p:sp>
-      <p:sp>
-        <p:nvSpPr>
-          <p:cNvPr id="17" name="TextBox 16"/>
-          <p:cNvSpPr txBox="1"/>
-          <p:nvPr/>
-        </p:nvSpPr>
-        <p:spPr>
-          <a:xfrm>
-            <a:off x="914400" y="4183380"/>
-            <a:ext cx="777240" cy="777240"/>
-          </a:xfrm>
-          <a:prstGeom prst="rect">
-            <a:avLst/>
-          </a:prstGeom>
-          <a:noFill/>
-        </p:spPr>
-        <p:txBody>
-          <a:bodyPr wrap="square" lIns="45720" rIns="45720" tIns="18288" bIns="18288" anchor="ctr">
-            <a:spAutoFit/>
-          </a:bodyPr>
-          <a:lstStyle/>
-          <a:p>
-            <a:pPr algn="ctr"/>
-            <a:r>
-              <a:rPr sz="2800" b="1" i="0">
-                <a:solidFill>
-                  <a:srgbClr val="FFFFFF"/>
-                </a:solidFill>
-                <a:latin typeface="Calibri"/>
-              </a:rPr>
-              <a:t>4</a:t>
-            </a:r>
-          </a:p>
-        </p:txBody>
-      </p:sp>
-      <p:sp>
-        <p:nvSpPr>
-          <p:cNvPr id="18" name="Rounded Rectangle 17"/>
-          <p:cNvSpPr/>
-          <p:nvPr/>
-        </p:nvSpPr>
-        <p:spPr>
-          <a:xfrm>
-            <a:off x="2011680" y="4183380"/>
-            <a:ext cx="9144000" cy="777240"/>
-          </a:xfrm>
-          <a:prstGeom prst="roundRect">
-            <a:avLst>
-              <a:gd name="adj" fmla="val 8000"/>
-            </a:avLst>
-          </a:prstGeom>
-          <a:solidFill>
-            <a:srgbClr val="FBFBFD"/>
-          </a:solidFill>
-          <a:ln w="19050">
-            <a:solidFill>
-              <a:srgbClr val="00A0B0"/>
-            </a:solidFill>
-          </a:ln>
-        </p:spPr>
-        <p:style>
-          <a:lnRef idx="1">
-            <a:schemeClr val="accent1"/>
-          </a:lnRef>
-          <a:fillRef idx="3">
-            <a:schemeClr val="accent1"/>
-          </a:fillRef>
-          <a:effectRef idx="2">
-            <a:schemeClr val="accent1"/>
-          </a:effectRef>
-          <a:fontRef idx="minor">
-            <a:schemeClr val="lt1"/>
-          </a:fontRef>
-        </p:style>
-        <p:txBody>
-          <a:bodyPr rtlCol="0" anchor="ctr"/>
-          <a:lstStyle/>
-          <a:p>
-            <a:pPr algn="ctr"/>
-          </a:p>
-        </p:txBody>
-      </p:sp>
-      <p:sp>
-        <p:nvSpPr>
-          <p:cNvPr id="19" name="TextBox 18"/>
-          <p:cNvSpPr txBox="1"/>
-          <p:nvPr/>
-        </p:nvSpPr>
-        <p:spPr>
-          <a:xfrm>
-            <a:off x="2286000" y="4183380"/>
-            <a:ext cx="8686800" cy="777240"/>
-          </a:xfrm>
-          <a:prstGeom prst="rect">
-            <a:avLst/>
-          </a:prstGeom>
-          <a:noFill/>
-        </p:spPr>
-        <p:txBody>
-          <a:bodyPr wrap="square" lIns="45720" rIns="45720" tIns="18288" bIns="18288" anchor="ctr">
-            <a:spAutoFit/>
-          </a:bodyPr>
-          <a:lstStyle/>
-          <a:p>
-            <a:pPr algn="l"/>
-            <a:r>
-              <a:rPr sz="1800" b="0" i="0">
+              <a:t>Compliance e legale (privacy policy, validation IBAN/CF)</a:t>
+            </a:r>
+          </a:p>
+          <a:p>
+            <a:pPr>
+              <a:lnSpc>
+                <a:spcPct val="150000"/>
+              </a:lnSpc>
+              <a:spcAft>
+                <a:spcPts val="400"/>
+              </a:spcAft>
+            </a:pPr>
+            <a:r>
+              <a:rPr sz="2000" b="1">
+                <a:solidFill>
+                  <a:srgbClr val="00A0B0"/>
+                </a:solidFill>
+                <a:latin typeface="Calibri"/>
+              </a:rPr>
+              <a:t>▸  </a:t>
+            </a:r>
+            <a:r>
+              <a:rPr sz="2000">
                 <a:solidFill>
                   <a:srgbClr val="1A1A2E"/>
                 </a:solidFill>
                 <a:latin typeface="Calibri"/>
               </a:rPr>
-              <a:t>I 7 errori tipici — riconoscerli a vista</a:t>
-            </a:r>
-          </a:p>
-        </p:txBody>
-      </p:sp>
-      <p:sp>
-        <p:nvSpPr>
-          <p:cNvPr id="20" name="Oval 19"/>
-          <p:cNvSpPr/>
-          <p:nvPr/>
-        </p:nvSpPr>
-        <p:spPr>
-          <a:xfrm>
-            <a:off x="914400" y="5097780"/>
-            <a:ext cx="777240" cy="777240"/>
-          </a:xfrm>
-          <a:prstGeom prst="ellipse">
-            <a:avLst/>
-          </a:prstGeom>
-          <a:solidFill>
-            <a:srgbClr val="00A0B0"/>
-          </a:solidFill>
-          <a:ln>
-            <a:noFill/>
-          </a:ln>
-        </p:spPr>
-        <p:style>
-          <a:lnRef idx="1">
-            <a:schemeClr val="accent1"/>
-          </a:lnRef>
-          <a:fillRef idx="3">
-            <a:schemeClr val="accent1"/>
-          </a:fillRef>
-          <a:effectRef idx="2">
-            <a:schemeClr val="accent1"/>
-          </a:effectRef>
-          <a:fontRef idx="minor">
-            <a:schemeClr val="lt1"/>
-          </a:fontRef>
-        </p:style>
-        <p:txBody>
-          <a:bodyPr rtlCol="0" anchor="ctr"/>
-          <a:lstStyle/>
-          <a:p>
-            <a:pPr algn="ctr"/>
-          </a:p>
-        </p:txBody>
-      </p:sp>
-      <p:sp>
-        <p:nvSpPr>
-          <p:cNvPr id="21" name="TextBox 20"/>
-          <p:cNvSpPr txBox="1"/>
-          <p:nvPr/>
-        </p:nvSpPr>
-        <p:spPr>
-          <a:xfrm>
-            <a:off x="914400" y="5097780"/>
-            <a:ext cx="777240" cy="777240"/>
-          </a:xfrm>
-          <a:prstGeom prst="rect">
-            <a:avLst/>
-          </a:prstGeom>
-          <a:noFill/>
-        </p:spPr>
-        <p:txBody>
-          <a:bodyPr wrap="square" lIns="45720" rIns="45720" tIns="18288" bIns="18288" anchor="ctr">
-            <a:spAutoFit/>
-          </a:bodyPr>
-          <a:lstStyle/>
-          <a:p>
-            <a:pPr algn="ctr"/>
-            <a:r>
-              <a:rPr sz="2800" b="1" i="0">
-                <a:solidFill>
-                  <a:srgbClr val="FFFFFF"/>
-                </a:solidFill>
-                <a:latin typeface="Calibri"/>
-              </a:rPr>
-              <a:t>5</a:t>
-            </a:r>
-          </a:p>
-        </p:txBody>
-      </p:sp>
-      <p:sp>
-        <p:nvSpPr>
-          <p:cNvPr id="22" name="Rounded Rectangle 21"/>
-          <p:cNvSpPr/>
-          <p:nvPr/>
-        </p:nvSpPr>
-        <p:spPr>
-          <a:xfrm>
-            <a:off x="2011680" y="5097780"/>
-            <a:ext cx="9144000" cy="777240"/>
-          </a:xfrm>
-          <a:prstGeom prst="roundRect">
-            <a:avLst>
-              <a:gd name="adj" fmla="val 8000"/>
-            </a:avLst>
-          </a:prstGeom>
-          <a:solidFill>
-            <a:srgbClr val="FBFBFD"/>
-          </a:solidFill>
-          <a:ln w="19050">
-            <a:solidFill>
-              <a:srgbClr val="00A0B0"/>
-            </a:solidFill>
-          </a:ln>
-        </p:spPr>
-        <p:style>
-          <a:lnRef idx="1">
-            <a:schemeClr val="accent1"/>
-          </a:lnRef>
-          <a:fillRef idx="3">
-            <a:schemeClr val="accent1"/>
-          </a:fillRef>
-          <a:effectRef idx="2">
-            <a:schemeClr val="accent1"/>
-          </a:effectRef>
-          <a:fontRef idx="minor">
-            <a:schemeClr val="lt1"/>
-          </a:fontRef>
-        </p:style>
-        <p:txBody>
-          <a:bodyPr rtlCol="0" anchor="ctr"/>
-          <a:lstStyle/>
-          <a:p>
-            <a:pPr algn="ctr"/>
-          </a:p>
-        </p:txBody>
-      </p:sp>
-      <p:sp>
-        <p:nvSpPr>
-          <p:cNvPr id="23" name="TextBox 22"/>
-          <p:cNvSpPr txBox="1"/>
-          <p:nvPr/>
-        </p:nvSpPr>
-        <p:spPr>
-          <a:xfrm>
-            <a:off x="2286000" y="5097780"/>
-            <a:ext cx="8686800" cy="777240"/>
-          </a:xfrm>
-          <a:prstGeom prst="rect">
-            <a:avLst/>
-          </a:prstGeom>
-          <a:noFill/>
-        </p:spPr>
-        <p:txBody>
-          <a:bodyPr wrap="square" lIns="45720" rIns="45720" tIns="18288" bIns="18288" anchor="ctr">
-            <a:spAutoFit/>
-          </a:bodyPr>
-          <a:lstStyle/>
-          <a:p>
-            <a:pPr algn="l"/>
-            <a:r>
-              <a:rPr sz="1800" b="0" i="0">
+              <a:t>Quando NON sai validare (impara prima)</a:t>
+            </a:r>
+          </a:p>
+          <a:p>
+            <a:pPr>
+              <a:lnSpc>
+                <a:spcPct val="150000"/>
+              </a:lnSpc>
+              <a:spcAft>
+                <a:spcPts val="400"/>
+              </a:spcAft>
+            </a:pPr>
+            <a:r>
+              <a:rPr sz="2000" b="1">
+                <a:solidFill>
+                  <a:srgbClr val="00A0B0"/>
+                </a:solidFill>
+                <a:latin typeface="Calibri"/>
+              </a:rPr>
+              <a:t>▸  </a:t>
+            </a:r>
+            <a:r>
+              <a:rPr sz="2000">
                 <a:solidFill>
                   <a:srgbClr val="1A1A2E"/>
                 </a:solidFill>
                 <a:latin typeface="Calibri"/>
               </a:rPr>
-              <a:t>Mai segreti nei prompt, mai crittografia da AI</a:t>
+              <a:t/>
+            </a:r>
+          </a:p>
+          <a:p>
+            <a:pPr>
+              <a:lnSpc>
+                <a:spcPct val="150000"/>
+              </a:lnSpc>
+              <a:spcAft>
+                <a:spcPts val="400"/>
+              </a:spcAft>
+            </a:pPr>
+            <a:r>
+              <a:rPr sz="2000" b="1">
+                <a:solidFill>
+                  <a:srgbClr val="00A0B0"/>
+                </a:solidFill>
+                <a:latin typeface="Calibri"/>
+              </a:rPr>
+              <a:t>▸  </a:t>
+            </a:r>
+            <a:r>
+              <a:rPr sz="2000">
+                <a:solidFill>
+                  <a:srgbClr val="1A1A2E"/>
+                </a:solidFill>
+                <a:latin typeface="Calibri"/>
+              </a:rPr>
+              <a:t>Caso reale: Samsung 2023</a:t>
+            </a:r>
+          </a:p>
+          <a:p>
+            <a:pPr>
+              <a:lnSpc>
+                <a:spcPct val="150000"/>
+              </a:lnSpc>
+              <a:spcAft>
+                <a:spcPts val="400"/>
+              </a:spcAft>
+            </a:pPr>
+            <a:r>
+              <a:rPr sz="2000" b="1">
+                <a:solidFill>
+                  <a:srgbClr val="00A0B0"/>
+                </a:solidFill>
+                <a:latin typeface="Calibri"/>
+              </a:rPr>
+              <a:t>▸  </a:t>
+            </a:r>
+            <a:r>
+              <a:rPr sz="2000">
+                <a:solidFill>
+                  <a:srgbClr val="1A1A2E"/>
+                </a:solidFill>
+                <a:latin typeface="Calibri"/>
+              </a:rPr>
+              <a:t>Dipendenti incollarono codice proprietario in ChatGPT</a:t>
+            </a:r>
+          </a:p>
+          <a:p>
+            <a:pPr>
+              <a:lnSpc>
+                <a:spcPct val="150000"/>
+              </a:lnSpc>
+              <a:spcAft>
+                <a:spcPts val="400"/>
+              </a:spcAft>
+            </a:pPr>
+            <a:r>
+              <a:rPr sz="2000" b="1">
+                <a:solidFill>
+                  <a:srgbClr val="00A0B0"/>
+                </a:solidFill>
+                <a:latin typeface="Calibri"/>
+              </a:rPr>
+              <a:t>▸  </a:t>
+            </a:r>
+            <a:r>
+              <a:rPr sz="2000">
+                <a:solidFill>
+                  <a:srgbClr val="1A1A2E"/>
+                </a:solidFill>
+                <a:latin typeface="Calibri"/>
+              </a:rPr>
+              <a:t>OpenAI lo usò per training → codice leakato indirettamente</a:t>
+            </a:r>
+          </a:p>
+          <a:p>
+            <a:pPr>
+              <a:lnSpc>
+                <a:spcPct val="150000"/>
+              </a:lnSpc>
+              <a:spcAft>
+                <a:spcPts val="400"/>
+              </a:spcAft>
+            </a:pPr>
+            <a:r>
+              <a:rPr sz="2000" b="1">
+                <a:solidFill>
+                  <a:srgbClr val="00A0B0"/>
+                </a:solidFill>
+                <a:latin typeface="Calibri"/>
+              </a:rPr>
+              <a:t>▸  </a:t>
+            </a:r>
+            <a:r>
+              <a:rPr sz="2000">
+                <a:solidFill>
+                  <a:srgbClr val="1A1A2E"/>
+                </a:solidFill>
+                <a:latin typeface="Calibri"/>
+              </a:rPr>
+              <a:t>Samsung dovette vietare ChatGPT internamente</a:t>
             </a:r>
           </a:p>
         </p:txBody>
       </p:sp>
       <p:cxnSp>
         <p:nvCxnSpPr>
-          <p:cNvPr id="24" name="Connector 23"/>
+          <p:cNvPr id="5" name="Connector 4"/>
           <p:cNvCxnSpPr/>
           <p:nvPr/>
         </p:nvCxnSpPr>
@@ -5520,7 +5638,7 @@
       </p:cxnSp>
       <p:sp>
         <p:nvSpPr>
-          <p:cNvPr id="25" name="TextBox 24"/>
+          <p:cNvPr id="6" name="TextBox 5"/>
           <p:cNvSpPr txBox="1"/>
           <p:nvPr/>
         </p:nvSpPr>
@@ -5555,7 +5673,7 @@
       </p:sp>
       <p:sp>
         <p:nvSpPr>
-          <p:cNvPr id="26" name="TextBox 25"/>
+          <p:cNvPr id="7" name="TextBox 6"/>
           <p:cNvSpPr txBox="1"/>
           <p:nvPr/>
         </p:nvSpPr>
@@ -5583,7 +5701,7 @@
                 </a:solidFill>
                 <a:latin typeface="Calibri"/>
               </a:rPr>
-              <a:t>L7  ·  12/14</a:t>
+              <a:t>L7  ·  12/16</a:t>
             </a:r>
           </a:p>
         </p:txBody>
@@ -5615,13 +5733,13 @@
         <p:spPr>
           <a:xfrm>
             <a:off x="0" y="0"/>
-            <a:ext cx="4114800" cy="6858000"/>
+            <a:ext cx="12191695" cy="777240"/>
           </a:xfrm>
           <a:prstGeom prst="rect">
             <a:avLst/>
           </a:prstGeom>
           <a:solidFill>
-            <a:srgbClr val="081B33"/>
+            <a:srgbClr val="0F2D52"/>
           </a:solidFill>
           <a:ln>
             <a:noFill/>
@@ -5651,100 +5769,49 @@
       </p:sp>
       <p:sp>
         <p:nvSpPr>
-          <p:cNvPr id="3" name="Rectangle 2"/>
-          <p:cNvSpPr/>
-          <p:nvPr/>
-        </p:nvSpPr>
-        <p:spPr>
-          <a:xfrm>
-            <a:off x="4114800" y="0"/>
-            <a:ext cx="8046720" cy="6858000"/>
+          <p:cNvPr id="3" name="TextBox 2"/>
+          <p:cNvSpPr txBox="1"/>
+          <p:nvPr/>
+        </p:nvSpPr>
+        <p:spPr>
+          <a:xfrm>
+            <a:off x="457200" y="164592"/>
+            <a:ext cx="10972800" cy="502920"/>
           </a:xfrm>
           <a:prstGeom prst="rect">
             <a:avLst/>
           </a:prstGeom>
-          <a:solidFill>
-            <a:srgbClr val="F1F4F8"/>
-          </a:solidFill>
-          <a:ln>
-            <a:noFill/>
-          </a:ln>
-        </p:spPr>
-        <p:style>
-          <a:lnRef idx="1">
-            <a:schemeClr val="accent1"/>
-          </a:lnRef>
-          <a:fillRef idx="3">
-            <a:schemeClr val="accent1"/>
-          </a:fillRef>
-          <a:effectRef idx="2">
-            <a:schemeClr val="accent1"/>
-          </a:effectRef>
-          <a:fontRef idx="minor">
-            <a:schemeClr val="lt1"/>
-          </a:fontRef>
-        </p:style>
-        <p:txBody>
-          <a:bodyPr rtlCol="0" anchor="ctr"/>
-          <a:lstStyle/>
-          <a:p>
-            <a:pPr algn="ctr"/>
-          </a:p>
-        </p:txBody>
-      </p:sp>
-      <p:sp>
-        <p:nvSpPr>
-          <p:cNvPr id="4" name="Rectangle 3"/>
-          <p:cNvSpPr/>
-          <p:nvPr/>
-        </p:nvSpPr>
-        <p:spPr>
-          <a:xfrm>
-            <a:off x="4114800" y="0"/>
-            <a:ext cx="137160" cy="6858000"/>
-          </a:xfrm>
-          <a:prstGeom prst="rect">
-            <a:avLst/>
-          </a:prstGeom>
-          <a:solidFill>
-            <a:srgbClr val="00A0B0"/>
-          </a:solidFill>
-          <a:ln>
-            <a:noFill/>
-          </a:ln>
-        </p:spPr>
-        <p:style>
-          <a:lnRef idx="1">
-            <a:schemeClr val="accent1"/>
-          </a:lnRef>
-          <a:fillRef idx="3">
-            <a:schemeClr val="accent1"/>
-          </a:fillRef>
-          <a:effectRef idx="2">
-            <a:schemeClr val="accent1"/>
-          </a:effectRef>
-          <a:fontRef idx="minor">
-            <a:schemeClr val="lt1"/>
-          </a:fontRef>
-        </p:style>
-        <p:txBody>
-          <a:bodyPr rtlCol="0" anchor="ctr"/>
-          <a:lstStyle/>
-          <a:p>
-            <a:pPr algn="ctr"/>
-          </a:p>
-        </p:txBody>
-      </p:sp>
-      <p:sp>
-        <p:nvSpPr>
-          <p:cNvPr id="5" name="TextBox 4"/>
+          <a:noFill/>
+        </p:spPr>
+        <p:txBody>
+          <a:bodyPr wrap="square" lIns="45720" rIns="45720" tIns="18288" bIns="18288" anchor="ctr">
+            <a:spAutoFit/>
+          </a:bodyPr>
+          <a:lstStyle/>
+          <a:p>
+            <a:pPr algn="l"/>
+            <a:r>
+              <a:rPr sz="2400" b="1" i="0">
+                <a:solidFill>
+                  <a:srgbClr val="FFFFFF"/>
+                </a:solidFill>
+                <a:latin typeface="Calibri"/>
+              </a:rPr>
+              <a:t>⚖  EU AI Act — la cornice normativa</a:t>
+            </a:r>
+          </a:p>
+        </p:txBody>
+      </p:sp>
+      <p:sp>
+        <p:nvSpPr>
+          <p:cNvPr id="4" name="TextBox 3"/>
           <p:cNvSpPr txBox="1"/>
           <p:nvPr/>
         </p:nvSpPr>
         <p:spPr>
           <a:xfrm>
-            <a:off x="274320" y="2103120"/>
-            <a:ext cx="3657600" cy="2286000"/>
+            <a:off x="457200" y="914400"/>
+            <a:ext cx="11247120" cy="457200"/>
           </a:xfrm>
           <a:prstGeom prst="rect">
             <a:avLst/>
@@ -5757,29 +5824,29 @@
           </a:bodyPr>
           <a:lstStyle/>
           <a:p>
-            <a:pPr algn="ctr"/>
-            <a:r>
-              <a:rPr sz="17000" b="1" i="0">
+            <a:pPr algn="l"/>
+            <a:r>
+              <a:rPr sz="1500" b="0" i="1">
                 <a:solidFill>
                   <a:srgbClr val="00A0B0"/>
                 </a:solidFill>
                 <a:latin typeface="Calibri"/>
               </a:rPr>
-              <a:t>03</a:t>
-            </a:r>
-          </a:p>
-        </p:txBody>
-      </p:sp>
-      <p:sp>
-        <p:nvSpPr>
-          <p:cNvPr id="6" name="TextBox 5"/>
+              <a:t>Sanzioni fino a 35M€ o 7% fatturato per sistemi proibiti</a:t>
+            </a:r>
+          </a:p>
+        </p:txBody>
+      </p:sp>
+      <p:sp>
+        <p:nvSpPr>
+          <p:cNvPr id="5" name="TextBox 4"/>
           <p:cNvSpPr txBox="1"/>
           <p:nvPr/>
         </p:nvSpPr>
         <p:spPr>
           <a:xfrm>
-            <a:off x="274320" y="4572000"/>
-            <a:ext cx="3657600" cy="457200"/>
+            <a:off x="640080" y="1554480"/>
+            <a:ext cx="10972800" cy="5029200"/>
           </a:xfrm>
           <a:prstGeom prst="rect">
             <a:avLst/>
@@ -5787,97 +5854,351 @@
           <a:noFill/>
         </p:spPr>
         <p:txBody>
-          <a:bodyPr wrap="square" lIns="45720" rIns="45720" tIns="18288" bIns="18288" anchor="t">
+          <a:bodyPr wrap="square">
             <a:spAutoFit/>
           </a:bodyPr>
           <a:lstStyle/>
           <a:p>
-            <a:pPr algn="ctr"/>
-            <a:r>
-              <a:rPr sz="2000" b="1" i="0">
-                <a:solidFill>
-                  <a:srgbClr val="6FD8E0"/>
-                </a:solidFill>
-                <a:latin typeface="Calibri"/>
-              </a:rPr>
-              <a:t>PARTE</a:t>
-            </a:r>
-          </a:p>
-        </p:txBody>
-      </p:sp>
-      <p:sp>
-        <p:nvSpPr>
-          <p:cNvPr id="7" name="TextBox 6"/>
-          <p:cNvSpPr txBox="1"/>
-          <p:nvPr/>
-        </p:nvSpPr>
-        <p:spPr>
-          <a:xfrm>
-            <a:off x="4572000" y="2286000"/>
-            <a:ext cx="7315200" cy="1645920"/>
-          </a:xfrm>
-          <a:prstGeom prst="rect">
-            <a:avLst/>
-          </a:prstGeom>
-          <a:noFill/>
-        </p:spPr>
-        <p:txBody>
-          <a:bodyPr wrap="square" lIns="45720" rIns="45720" tIns="18288" bIns="18288" anchor="t">
-            <a:spAutoFit/>
-          </a:bodyPr>
-          <a:lstStyle/>
-          <a:p>
-            <a:pPr algn="l"/>
-            <a:r>
-              <a:rPr sz="4400" b="1" i="0">
-                <a:solidFill>
-                  <a:srgbClr val="0F2D52"/>
-                </a:solidFill>
-                <a:latin typeface="Calibri"/>
-              </a:rPr>
-              <a:t>Lab in aula</a:t>
-            </a:r>
-          </a:p>
-        </p:txBody>
-      </p:sp>
-      <p:sp>
-        <p:nvSpPr>
-          <p:cNvPr id="8" name="TextBox 7"/>
-          <p:cNvSpPr txBox="1"/>
-          <p:nvPr/>
-        </p:nvSpPr>
-        <p:spPr>
-          <a:xfrm>
-            <a:off x="4572000" y="3931920"/>
-            <a:ext cx="7315200" cy="1828800"/>
-          </a:xfrm>
-          <a:prstGeom prst="rect">
-            <a:avLst/>
-          </a:prstGeom>
-          <a:noFill/>
-        </p:spPr>
-        <p:txBody>
-          <a:bodyPr wrap="square" lIns="45720" rIns="45720" tIns="18288" bIns="18288" anchor="t">
-            <a:spAutoFit/>
-          </a:bodyPr>
-          <a:lstStyle/>
-          <a:p>
-            <a:pPr algn="l"/>
-            <a:r>
-              <a:rPr sz="1800" b="0" i="1">
-                <a:solidFill>
-                  <a:srgbClr val="6B7280"/>
-                </a:solidFill>
-                <a:latin typeface="Calibri"/>
-              </a:rPr>
-              <a:t>Validation collettiva di codice AI vulnerabile</a:t>
+            <a:pPr>
+              <a:lnSpc>
+                <a:spcPct val="150000"/>
+              </a:lnSpc>
+              <a:spcAft>
+                <a:spcPts val="400"/>
+              </a:spcAft>
+            </a:pPr>
+            <a:r>
+              <a:rPr sz="2000" b="1">
+                <a:solidFill>
+                  <a:srgbClr val="00A0B0"/>
+                </a:solidFill>
+                <a:latin typeface="Calibri"/>
+              </a:rPr>
+              <a:t>▸  </a:t>
+            </a:r>
+            <a:r>
+              <a:rPr sz="2000">
+                <a:solidFill>
+                  <a:srgbClr val="1A1A2E"/>
+                </a:solidFill>
+                <a:latin typeface="Calibri"/>
+              </a:rPr>
+              <a:t>Regolamento (UE) 2024/1689 — in vigore agosto 2024</a:t>
+            </a:r>
+          </a:p>
+          <a:p>
+            <a:pPr>
+              <a:lnSpc>
+                <a:spcPct val="150000"/>
+              </a:lnSpc>
+              <a:spcAft>
+                <a:spcPts val="400"/>
+              </a:spcAft>
+            </a:pPr>
+            <a:r>
+              <a:rPr sz="2000" b="1">
+                <a:solidFill>
+                  <a:srgbClr val="00A0B0"/>
+                </a:solidFill>
+                <a:latin typeface="Calibri"/>
+              </a:rPr>
+              <a:t>▸  </a:t>
+            </a:r>
+            <a:r>
+              <a:rPr sz="2000">
+                <a:solidFill>
+                  <a:srgbClr val="1A1A2E"/>
+                </a:solidFill>
+                <a:latin typeface="Calibri"/>
+              </a:rPr>
+              <a:t>Piena applicazione: agosto 2026 — alcune disposizioni 2027</a:t>
+            </a:r>
+          </a:p>
+          <a:p>
+            <a:pPr>
+              <a:lnSpc>
+                <a:spcPct val="150000"/>
+              </a:lnSpc>
+              <a:spcAft>
+                <a:spcPts val="400"/>
+              </a:spcAft>
+            </a:pPr>
+            <a:r>
+              <a:rPr sz="2000" b="1">
+                <a:solidFill>
+                  <a:srgbClr val="00A0B0"/>
+                </a:solidFill>
+                <a:latin typeface="Calibri"/>
+              </a:rPr>
+              <a:t>▸  </a:t>
+            </a:r>
+            <a:r>
+              <a:rPr sz="2000">
+                <a:solidFill>
+                  <a:srgbClr val="1A1A2E"/>
+                </a:solidFill>
+                <a:latin typeface="Calibri"/>
+              </a:rPr>
+              <a:t/>
+            </a:r>
+          </a:p>
+          <a:p>
+            <a:pPr>
+              <a:lnSpc>
+                <a:spcPct val="150000"/>
+              </a:lnSpc>
+              <a:spcAft>
+                <a:spcPts val="400"/>
+              </a:spcAft>
+            </a:pPr>
+            <a:r>
+              <a:rPr sz="2000" b="1">
+                <a:solidFill>
+                  <a:srgbClr val="00A0B0"/>
+                </a:solidFill>
+                <a:latin typeface="Calibri"/>
+              </a:rPr>
+              <a:t>▸  </a:t>
+            </a:r>
+            <a:r>
+              <a:rPr sz="2000">
+                <a:solidFill>
+                  <a:srgbClr val="1A1A2E"/>
+                </a:solidFill>
+                <a:latin typeface="Calibri"/>
+              </a:rPr>
+              <a:t>Approccio risk-based: 4 categorie</a:t>
+            </a:r>
+          </a:p>
+          <a:p>
+            <a:pPr>
+              <a:lnSpc>
+                <a:spcPct val="150000"/>
+              </a:lnSpc>
+              <a:spcAft>
+                <a:spcPts val="400"/>
+              </a:spcAft>
+            </a:pPr>
+            <a:r>
+              <a:rPr sz="2000" b="1">
+                <a:solidFill>
+                  <a:srgbClr val="00A0B0"/>
+                </a:solidFill>
+                <a:latin typeface="Calibri"/>
+              </a:rPr>
+              <a:t>▸  </a:t>
+            </a:r>
+            <a:r>
+              <a:rPr sz="2000">
+                <a:solidFill>
+                  <a:srgbClr val="1A1A2E"/>
+                </a:solidFill>
+                <a:latin typeface="Calibri"/>
+              </a:rPr>
+              <a:t>  Rischio INACCETTABILE → vietati (social scoring, ecc.)</a:t>
+            </a:r>
+          </a:p>
+          <a:p>
+            <a:pPr>
+              <a:lnSpc>
+                <a:spcPct val="150000"/>
+              </a:lnSpc>
+              <a:spcAft>
+                <a:spcPts val="400"/>
+              </a:spcAft>
+            </a:pPr>
+            <a:r>
+              <a:rPr sz="2000" b="1">
+                <a:solidFill>
+                  <a:srgbClr val="00A0B0"/>
+                </a:solidFill>
+                <a:latin typeface="Calibri"/>
+              </a:rPr>
+              <a:t>▸  </a:t>
+            </a:r>
+            <a:r>
+              <a:rPr sz="2000">
+                <a:solidFill>
+                  <a:srgbClr val="1A1A2E"/>
+                </a:solidFill>
+                <a:latin typeface="Calibri"/>
+              </a:rPr>
+              <a:t>  Rischio ALTO → obblighi stringenti (recruitment, scoring credito)</a:t>
+            </a:r>
+          </a:p>
+          <a:p>
+            <a:pPr>
+              <a:lnSpc>
+                <a:spcPct val="150000"/>
+              </a:lnSpc>
+              <a:spcAft>
+                <a:spcPts val="400"/>
+              </a:spcAft>
+            </a:pPr>
+            <a:r>
+              <a:rPr sz="2000" b="1">
+                <a:solidFill>
+                  <a:srgbClr val="00A0B0"/>
+                </a:solidFill>
+                <a:latin typeface="Calibri"/>
+              </a:rPr>
+              <a:t>▸  </a:t>
+            </a:r>
+            <a:r>
+              <a:rPr sz="2000">
+                <a:solidFill>
+                  <a:srgbClr val="1A1A2E"/>
+                </a:solidFill>
+                <a:latin typeface="Calibri"/>
+              </a:rPr>
+              <a:t>  Rischio LIMITATO → trasparenza (chatbot, deepfake)</a:t>
+            </a:r>
+          </a:p>
+          <a:p>
+            <a:pPr>
+              <a:lnSpc>
+                <a:spcPct val="150000"/>
+              </a:lnSpc>
+              <a:spcAft>
+                <a:spcPts val="400"/>
+              </a:spcAft>
+            </a:pPr>
+            <a:r>
+              <a:rPr sz="2000" b="1">
+                <a:solidFill>
+                  <a:srgbClr val="00A0B0"/>
+                </a:solidFill>
+                <a:latin typeface="Calibri"/>
+              </a:rPr>
+              <a:t>▸  </a:t>
+            </a:r>
+            <a:r>
+              <a:rPr sz="2000">
+                <a:solidFill>
+                  <a:srgbClr val="1A1A2E"/>
+                </a:solidFill>
+                <a:latin typeface="Calibri"/>
+              </a:rPr>
+              <a:t>  Rischio MINIMO → liberi (la maggioranza)</a:t>
+            </a:r>
+          </a:p>
+          <a:p>
+            <a:pPr>
+              <a:lnSpc>
+                <a:spcPct val="150000"/>
+              </a:lnSpc>
+              <a:spcAft>
+                <a:spcPts val="400"/>
+              </a:spcAft>
+            </a:pPr>
+            <a:r>
+              <a:rPr sz="2000" b="1">
+                <a:solidFill>
+                  <a:srgbClr val="00A0B0"/>
+                </a:solidFill>
+                <a:latin typeface="Calibri"/>
+              </a:rPr>
+              <a:t>▸  </a:t>
+            </a:r>
+            <a:r>
+              <a:rPr sz="2000">
+                <a:solidFill>
+                  <a:srgbClr val="1A1A2E"/>
+                </a:solidFill>
+                <a:latin typeface="Calibri"/>
+              </a:rPr>
+              <a:t/>
+            </a:r>
+          </a:p>
+          <a:p>
+            <a:pPr>
+              <a:lnSpc>
+                <a:spcPct val="150000"/>
+              </a:lnSpc>
+              <a:spcAft>
+                <a:spcPts val="400"/>
+              </a:spcAft>
+            </a:pPr>
+            <a:r>
+              <a:rPr sz="2000" b="1">
+                <a:solidFill>
+                  <a:srgbClr val="00A0B0"/>
+                </a:solidFill>
+                <a:latin typeface="Calibri"/>
+              </a:rPr>
+              <a:t>▸  </a:t>
+            </a:r>
+            <a:r>
+              <a:rPr sz="2000">
+                <a:solidFill>
+                  <a:srgbClr val="1A1A2E"/>
+                </a:solidFill>
+                <a:latin typeface="Calibri"/>
+              </a:rPr>
+              <a:t>Per chi USA AI per scrivere codice: nessun obbligo diretto</a:t>
+            </a:r>
+          </a:p>
+          <a:p>
+            <a:pPr>
+              <a:lnSpc>
+                <a:spcPct val="150000"/>
+              </a:lnSpc>
+              <a:spcAft>
+                <a:spcPts val="400"/>
+              </a:spcAft>
+            </a:pPr>
+            <a:r>
+              <a:rPr sz="2000" b="1">
+                <a:solidFill>
+                  <a:srgbClr val="00A0B0"/>
+                </a:solidFill>
+                <a:latin typeface="Calibri"/>
+              </a:rPr>
+              <a:t>▸  </a:t>
+            </a:r>
+            <a:r>
+              <a:rPr sz="2000">
+                <a:solidFill>
+                  <a:srgbClr val="1A1A2E"/>
+                </a:solidFill>
+                <a:latin typeface="Calibri"/>
+              </a:rPr>
+              <a:t>Per chi INTEGRA AI ad alto rischio in prodotti: documentazione,</a:t>
+            </a:r>
+          </a:p>
+          <a:p>
+            <a:pPr>
+              <a:lnSpc>
+                <a:spcPct val="150000"/>
+              </a:lnSpc>
+              <a:spcAft>
+                <a:spcPts val="400"/>
+              </a:spcAft>
+            </a:pPr>
+            <a:r>
+              <a:rPr sz="2000" b="1">
+                <a:solidFill>
+                  <a:srgbClr val="00A0B0"/>
+                </a:solidFill>
+                <a:latin typeface="Calibri"/>
+              </a:rPr>
+              <a:t>▸  </a:t>
+            </a:r>
+            <a:r>
+              <a:rPr sz="2000">
+                <a:solidFill>
+                  <a:srgbClr val="1A1A2E"/>
+                </a:solidFill>
+                <a:latin typeface="Calibri"/>
+              </a:rPr>
+              <a:t>trasparenza, supervisione umana, dataset governance</a:t>
             </a:r>
           </a:p>
         </p:txBody>
       </p:sp>
       <p:cxnSp>
         <p:nvCxnSpPr>
-          <p:cNvPr id="9" name="Connector 8"/>
+          <p:cNvPr id="6" name="Connector 5"/>
           <p:cNvCxnSpPr/>
           <p:nvPr/>
         </p:nvCxnSpPr>
@@ -5912,7 +6233,7 @@
       </p:cxnSp>
       <p:sp>
         <p:nvSpPr>
-          <p:cNvPr id="10" name="TextBox 9"/>
+          <p:cNvPr id="7" name="TextBox 6"/>
           <p:cNvSpPr txBox="1"/>
           <p:nvPr/>
         </p:nvSpPr>
@@ -5947,7 +6268,7 @@
       </p:sp>
       <p:sp>
         <p:nvSpPr>
-          <p:cNvPr id="11" name="TextBox 10"/>
+          <p:cNvPr id="8" name="TextBox 7"/>
           <p:cNvSpPr txBox="1"/>
           <p:nvPr/>
         </p:nvSpPr>
@@ -5975,7 +6296,7 @@
                 </a:solidFill>
                 <a:latin typeface="Calibri"/>
               </a:rPr>
-              <a:t>L7  ·  13/14</a:t>
+              <a:t>L7  ·  13/16</a:t>
             </a:r>
           </a:p>
         </p:txBody>
@@ -6007,7 +6328,1008 @@
         <p:spPr>
           <a:xfrm>
             <a:off x="0" y="0"/>
-            <a:ext cx="12191695" cy="6858000"/>
+            <a:ext cx="12191695" cy="777240"/>
+          </a:xfrm>
+          <a:prstGeom prst="rect">
+            <a:avLst/>
+          </a:prstGeom>
+          <a:solidFill>
+            <a:srgbClr val="0F2D52"/>
+          </a:solidFill>
+          <a:ln>
+            <a:noFill/>
+          </a:ln>
+        </p:spPr>
+        <p:style>
+          <a:lnRef idx="1">
+            <a:schemeClr val="accent1"/>
+          </a:lnRef>
+          <a:fillRef idx="3">
+            <a:schemeClr val="accent1"/>
+          </a:fillRef>
+          <a:effectRef idx="2">
+            <a:schemeClr val="accent1"/>
+          </a:effectRef>
+          <a:fontRef idx="minor">
+            <a:schemeClr val="lt1"/>
+          </a:fontRef>
+        </p:style>
+        <p:txBody>
+          <a:bodyPr rtlCol="0" anchor="ctr"/>
+          <a:lstStyle/>
+          <a:p>
+            <a:pPr algn="ctr"/>
+          </a:p>
+        </p:txBody>
+      </p:sp>
+      <p:sp>
+        <p:nvSpPr>
+          <p:cNvPr id="3" name="TextBox 2"/>
+          <p:cNvSpPr txBox="1"/>
+          <p:nvPr/>
+        </p:nvSpPr>
+        <p:spPr>
+          <a:xfrm>
+            <a:off x="457200" y="164592"/>
+            <a:ext cx="10972800" cy="502920"/>
+          </a:xfrm>
+          <a:prstGeom prst="rect">
+            <a:avLst/>
+          </a:prstGeom>
+          <a:noFill/>
+        </p:spPr>
+        <p:txBody>
+          <a:bodyPr wrap="square" lIns="45720" rIns="45720" tIns="18288" bIns="18288" anchor="ctr">
+            <a:spAutoFit/>
+          </a:bodyPr>
+          <a:lstStyle/>
+          <a:p>
+            <a:pPr algn="l"/>
+            <a:r>
+              <a:rPr sz="2400" b="1" i="0">
+                <a:solidFill>
+                  <a:srgbClr val="FFFFFF"/>
+                </a:solidFill>
+                <a:latin typeface="Calibri"/>
+              </a:rPr>
+              <a:t>📌  Cosa portare a casa</a:t>
+            </a:r>
+          </a:p>
+        </p:txBody>
+      </p:sp>
+      <p:sp>
+        <p:nvSpPr>
+          <p:cNvPr id="4" name="Oval 3"/>
+          <p:cNvSpPr/>
+          <p:nvPr/>
+        </p:nvSpPr>
+        <p:spPr>
+          <a:xfrm>
+            <a:off x="914400" y="1440180"/>
+            <a:ext cx="777240" cy="777240"/>
+          </a:xfrm>
+          <a:prstGeom prst="ellipse">
+            <a:avLst/>
+          </a:prstGeom>
+          <a:solidFill>
+            <a:srgbClr val="00A0B0"/>
+          </a:solidFill>
+          <a:ln>
+            <a:noFill/>
+          </a:ln>
+        </p:spPr>
+        <p:style>
+          <a:lnRef idx="1">
+            <a:schemeClr val="accent1"/>
+          </a:lnRef>
+          <a:fillRef idx="3">
+            <a:schemeClr val="accent1"/>
+          </a:fillRef>
+          <a:effectRef idx="2">
+            <a:schemeClr val="accent1"/>
+          </a:effectRef>
+          <a:fontRef idx="minor">
+            <a:schemeClr val="lt1"/>
+          </a:fontRef>
+        </p:style>
+        <p:txBody>
+          <a:bodyPr rtlCol="0" anchor="ctr"/>
+          <a:lstStyle/>
+          <a:p>
+            <a:pPr algn="ctr"/>
+          </a:p>
+        </p:txBody>
+      </p:sp>
+      <p:sp>
+        <p:nvSpPr>
+          <p:cNvPr id="5" name="TextBox 4"/>
+          <p:cNvSpPr txBox="1"/>
+          <p:nvPr/>
+        </p:nvSpPr>
+        <p:spPr>
+          <a:xfrm>
+            <a:off x="914400" y="1440180"/>
+            <a:ext cx="777240" cy="777240"/>
+          </a:xfrm>
+          <a:prstGeom prst="rect">
+            <a:avLst/>
+          </a:prstGeom>
+          <a:noFill/>
+        </p:spPr>
+        <p:txBody>
+          <a:bodyPr wrap="square" lIns="45720" rIns="45720" tIns="18288" bIns="18288" anchor="ctr">
+            <a:spAutoFit/>
+          </a:bodyPr>
+          <a:lstStyle/>
+          <a:p>
+            <a:pPr algn="ctr"/>
+            <a:r>
+              <a:rPr sz="2800" b="1" i="0">
+                <a:solidFill>
+                  <a:srgbClr val="FFFFFF"/>
+                </a:solidFill>
+                <a:latin typeface="Calibri"/>
+              </a:rPr>
+              <a:t>1</a:t>
+            </a:r>
+          </a:p>
+        </p:txBody>
+      </p:sp>
+      <p:sp>
+        <p:nvSpPr>
+          <p:cNvPr id="6" name="Rounded Rectangle 5"/>
+          <p:cNvSpPr/>
+          <p:nvPr/>
+        </p:nvSpPr>
+        <p:spPr>
+          <a:xfrm>
+            <a:off x="2011680" y="1440180"/>
+            <a:ext cx="9144000" cy="777240"/>
+          </a:xfrm>
+          <a:prstGeom prst="roundRect">
+            <a:avLst>
+              <a:gd name="adj" fmla="val 8000"/>
+            </a:avLst>
+          </a:prstGeom>
+          <a:solidFill>
+            <a:srgbClr val="FBFBFD"/>
+          </a:solidFill>
+          <a:ln w="19050">
+            <a:solidFill>
+              <a:srgbClr val="00A0B0"/>
+            </a:solidFill>
+          </a:ln>
+        </p:spPr>
+        <p:style>
+          <a:lnRef idx="1">
+            <a:schemeClr val="accent1"/>
+          </a:lnRef>
+          <a:fillRef idx="3">
+            <a:schemeClr val="accent1"/>
+          </a:fillRef>
+          <a:effectRef idx="2">
+            <a:schemeClr val="accent1"/>
+          </a:effectRef>
+          <a:fontRef idx="minor">
+            <a:schemeClr val="lt1"/>
+          </a:fontRef>
+        </p:style>
+        <p:txBody>
+          <a:bodyPr rtlCol="0" anchor="ctr"/>
+          <a:lstStyle/>
+          <a:p>
+            <a:pPr algn="ctr"/>
+          </a:p>
+        </p:txBody>
+      </p:sp>
+      <p:sp>
+        <p:nvSpPr>
+          <p:cNvPr id="7" name="TextBox 6"/>
+          <p:cNvSpPr txBox="1"/>
+          <p:nvPr/>
+        </p:nvSpPr>
+        <p:spPr>
+          <a:xfrm>
+            <a:off x="2286000" y="1440180"/>
+            <a:ext cx="8686800" cy="777240"/>
+          </a:xfrm>
+          <a:prstGeom prst="rect">
+            <a:avLst/>
+          </a:prstGeom>
+          <a:noFill/>
+        </p:spPr>
+        <p:txBody>
+          <a:bodyPr wrap="square" lIns="45720" rIns="45720" tIns="18288" bIns="18288" anchor="ctr">
+            <a:spAutoFit/>
+          </a:bodyPr>
+          <a:lstStyle/>
+          <a:p>
+            <a:pPr algn="l"/>
+            <a:r>
+              <a:rPr sz="1800" b="0" i="0">
+                <a:solidFill>
+                  <a:srgbClr val="1A1A2E"/>
+                </a:solidFill>
+                <a:latin typeface="Calibri"/>
+              </a:rPr>
+              <a:t>Documentare la sicurezza è un REQUISITO legale e operativo</a:t>
+            </a:r>
+          </a:p>
+        </p:txBody>
+      </p:sp>
+      <p:sp>
+        <p:nvSpPr>
+          <p:cNvPr id="8" name="Oval 7"/>
+          <p:cNvSpPr/>
+          <p:nvPr/>
+        </p:nvSpPr>
+        <p:spPr>
+          <a:xfrm>
+            <a:off x="914400" y="2354580"/>
+            <a:ext cx="777240" cy="777240"/>
+          </a:xfrm>
+          <a:prstGeom prst="ellipse">
+            <a:avLst/>
+          </a:prstGeom>
+          <a:solidFill>
+            <a:srgbClr val="00A0B0"/>
+          </a:solidFill>
+          <a:ln>
+            <a:noFill/>
+          </a:ln>
+        </p:spPr>
+        <p:style>
+          <a:lnRef idx="1">
+            <a:schemeClr val="accent1"/>
+          </a:lnRef>
+          <a:fillRef idx="3">
+            <a:schemeClr val="accent1"/>
+          </a:fillRef>
+          <a:effectRef idx="2">
+            <a:schemeClr val="accent1"/>
+          </a:effectRef>
+          <a:fontRef idx="minor">
+            <a:schemeClr val="lt1"/>
+          </a:fontRef>
+        </p:style>
+        <p:txBody>
+          <a:bodyPr rtlCol="0" anchor="ctr"/>
+          <a:lstStyle/>
+          <a:p>
+            <a:pPr algn="ctr"/>
+          </a:p>
+        </p:txBody>
+      </p:sp>
+      <p:sp>
+        <p:nvSpPr>
+          <p:cNvPr id="9" name="TextBox 8"/>
+          <p:cNvSpPr txBox="1"/>
+          <p:nvPr/>
+        </p:nvSpPr>
+        <p:spPr>
+          <a:xfrm>
+            <a:off x="914400" y="2354580"/>
+            <a:ext cx="777240" cy="777240"/>
+          </a:xfrm>
+          <a:prstGeom prst="rect">
+            <a:avLst/>
+          </a:prstGeom>
+          <a:noFill/>
+        </p:spPr>
+        <p:txBody>
+          <a:bodyPr wrap="square" lIns="45720" rIns="45720" tIns="18288" bIns="18288" anchor="ctr">
+            <a:spAutoFit/>
+          </a:bodyPr>
+          <a:lstStyle/>
+          <a:p>
+            <a:pPr algn="ctr"/>
+            <a:r>
+              <a:rPr sz="2800" b="1" i="0">
+                <a:solidFill>
+                  <a:srgbClr val="FFFFFF"/>
+                </a:solidFill>
+                <a:latin typeface="Calibri"/>
+              </a:rPr>
+              <a:t>2</a:t>
+            </a:r>
+          </a:p>
+        </p:txBody>
+      </p:sp>
+      <p:sp>
+        <p:nvSpPr>
+          <p:cNvPr id="10" name="Rounded Rectangle 9"/>
+          <p:cNvSpPr/>
+          <p:nvPr/>
+        </p:nvSpPr>
+        <p:spPr>
+          <a:xfrm>
+            <a:off x="2011680" y="2354580"/>
+            <a:ext cx="9144000" cy="777240"/>
+          </a:xfrm>
+          <a:prstGeom prst="roundRect">
+            <a:avLst>
+              <a:gd name="adj" fmla="val 8000"/>
+            </a:avLst>
+          </a:prstGeom>
+          <a:solidFill>
+            <a:srgbClr val="FBFBFD"/>
+          </a:solidFill>
+          <a:ln w="19050">
+            <a:solidFill>
+              <a:srgbClr val="00A0B0"/>
+            </a:solidFill>
+          </a:ln>
+        </p:spPr>
+        <p:style>
+          <a:lnRef idx="1">
+            <a:schemeClr val="accent1"/>
+          </a:lnRef>
+          <a:fillRef idx="3">
+            <a:schemeClr val="accent1"/>
+          </a:fillRef>
+          <a:effectRef idx="2">
+            <a:schemeClr val="accent1"/>
+          </a:effectRef>
+          <a:fontRef idx="minor">
+            <a:schemeClr val="lt1"/>
+          </a:fontRef>
+        </p:style>
+        <p:txBody>
+          <a:bodyPr rtlCol="0" anchor="ctr"/>
+          <a:lstStyle/>
+          <a:p>
+            <a:pPr algn="ctr"/>
+          </a:p>
+        </p:txBody>
+      </p:sp>
+      <p:sp>
+        <p:nvSpPr>
+          <p:cNvPr id="11" name="TextBox 10"/>
+          <p:cNvSpPr txBox="1"/>
+          <p:nvPr/>
+        </p:nvSpPr>
+        <p:spPr>
+          <a:xfrm>
+            <a:off x="2286000" y="2354580"/>
+            <a:ext cx="8686800" cy="777240"/>
+          </a:xfrm>
+          <a:prstGeom prst="rect">
+            <a:avLst/>
+          </a:prstGeom>
+          <a:noFill/>
+        </p:spPr>
+        <p:txBody>
+          <a:bodyPr wrap="square" lIns="45720" rIns="45720" tIns="18288" bIns="18288" anchor="ctr">
+            <a:spAutoFit/>
+          </a:bodyPr>
+          <a:lstStyle/>
+          <a:p>
+            <a:pPr algn="l"/>
+            <a:r>
+              <a:rPr sz="1800" b="0" i="0">
+                <a:solidFill>
+                  <a:srgbClr val="1A1A2E"/>
+                </a:solidFill>
+                <a:latin typeface="Calibri"/>
+              </a:rPr>
+              <a:t>SECURITY.md versionato con il codice</a:t>
+            </a:r>
+          </a:p>
+        </p:txBody>
+      </p:sp>
+      <p:sp>
+        <p:nvSpPr>
+          <p:cNvPr id="12" name="Oval 11"/>
+          <p:cNvSpPr/>
+          <p:nvPr/>
+        </p:nvSpPr>
+        <p:spPr>
+          <a:xfrm>
+            <a:off x="914400" y="3268980"/>
+            <a:ext cx="777240" cy="777240"/>
+          </a:xfrm>
+          <a:prstGeom prst="ellipse">
+            <a:avLst/>
+          </a:prstGeom>
+          <a:solidFill>
+            <a:srgbClr val="00A0B0"/>
+          </a:solidFill>
+          <a:ln>
+            <a:noFill/>
+          </a:ln>
+        </p:spPr>
+        <p:style>
+          <a:lnRef idx="1">
+            <a:schemeClr val="accent1"/>
+          </a:lnRef>
+          <a:fillRef idx="3">
+            <a:schemeClr val="accent1"/>
+          </a:fillRef>
+          <a:effectRef idx="2">
+            <a:schemeClr val="accent1"/>
+          </a:effectRef>
+          <a:fontRef idx="minor">
+            <a:schemeClr val="lt1"/>
+          </a:fontRef>
+        </p:style>
+        <p:txBody>
+          <a:bodyPr rtlCol="0" anchor="ctr"/>
+          <a:lstStyle/>
+          <a:p>
+            <a:pPr algn="ctr"/>
+          </a:p>
+        </p:txBody>
+      </p:sp>
+      <p:sp>
+        <p:nvSpPr>
+          <p:cNvPr id="13" name="TextBox 12"/>
+          <p:cNvSpPr txBox="1"/>
+          <p:nvPr/>
+        </p:nvSpPr>
+        <p:spPr>
+          <a:xfrm>
+            <a:off x="914400" y="3268980"/>
+            <a:ext cx="777240" cy="777240"/>
+          </a:xfrm>
+          <a:prstGeom prst="rect">
+            <a:avLst/>
+          </a:prstGeom>
+          <a:noFill/>
+        </p:spPr>
+        <p:txBody>
+          <a:bodyPr wrap="square" lIns="45720" rIns="45720" tIns="18288" bIns="18288" anchor="ctr">
+            <a:spAutoFit/>
+          </a:bodyPr>
+          <a:lstStyle/>
+          <a:p>
+            <a:pPr algn="ctr"/>
+            <a:r>
+              <a:rPr sz="2800" b="1" i="0">
+                <a:solidFill>
+                  <a:srgbClr val="FFFFFF"/>
+                </a:solidFill>
+                <a:latin typeface="Calibri"/>
+              </a:rPr>
+              <a:t>3</a:t>
+            </a:r>
+          </a:p>
+        </p:txBody>
+      </p:sp>
+      <p:sp>
+        <p:nvSpPr>
+          <p:cNvPr id="14" name="Rounded Rectangle 13"/>
+          <p:cNvSpPr/>
+          <p:nvPr/>
+        </p:nvSpPr>
+        <p:spPr>
+          <a:xfrm>
+            <a:off x="2011680" y="3268980"/>
+            <a:ext cx="9144000" cy="777240"/>
+          </a:xfrm>
+          <a:prstGeom prst="roundRect">
+            <a:avLst>
+              <a:gd name="adj" fmla="val 8000"/>
+            </a:avLst>
+          </a:prstGeom>
+          <a:solidFill>
+            <a:srgbClr val="FBFBFD"/>
+          </a:solidFill>
+          <a:ln w="19050">
+            <a:solidFill>
+              <a:srgbClr val="00A0B0"/>
+            </a:solidFill>
+          </a:ln>
+        </p:spPr>
+        <p:style>
+          <a:lnRef idx="1">
+            <a:schemeClr val="accent1"/>
+          </a:lnRef>
+          <a:fillRef idx="3">
+            <a:schemeClr val="accent1"/>
+          </a:fillRef>
+          <a:effectRef idx="2">
+            <a:schemeClr val="accent1"/>
+          </a:effectRef>
+          <a:fontRef idx="minor">
+            <a:schemeClr val="lt1"/>
+          </a:fontRef>
+        </p:style>
+        <p:txBody>
+          <a:bodyPr rtlCol="0" anchor="ctr"/>
+          <a:lstStyle/>
+          <a:p>
+            <a:pPr algn="ctr"/>
+          </a:p>
+        </p:txBody>
+      </p:sp>
+      <p:sp>
+        <p:nvSpPr>
+          <p:cNvPr id="15" name="TextBox 14"/>
+          <p:cNvSpPr txBox="1"/>
+          <p:nvPr/>
+        </p:nvSpPr>
+        <p:spPr>
+          <a:xfrm>
+            <a:off x="2286000" y="3268980"/>
+            <a:ext cx="8686800" cy="777240"/>
+          </a:xfrm>
+          <a:prstGeom prst="rect">
+            <a:avLst/>
+          </a:prstGeom>
+          <a:noFill/>
+        </p:spPr>
+        <p:txBody>
+          <a:bodyPr wrap="square" lIns="45720" rIns="45720" tIns="18288" bIns="18288" anchor="ctr">
+            <a:spAutoFit/>
+          </a:bodyPr>
+          <a:lstStyle/>
+          <a:p>
+            <a:pPr algn="l"/>
+            <a:r>
+              <a:rPr sz="1800" b="0" i="0">
+                <a:solidFill>
+                  <a:srgbClr val="1A1A2E"/>
+                </a:solidFill>
+                <a:latin typeface="Calibri"/>
+              </a:rPr>
+              <a:t>L'IA non sa di sicurezza: validare ogni suggerimento</a:t>
+            </a:r>
+          </a:p>
+        </p:txBody>
+      </p:sp>
+      <p:sp>
+        <p:nvSpPr>
+          <p:cNvPr id="16" name="Oval 15"/>
+          <p:cNvSpPr/>
+          <p:nvPr/>
+        </p:nvSpPr>
+        <p:spPr>
+          <a:xfrm>
+            <a:off x="914400" y="4183380"/>
+            <a:ext cx="777240" cy="777240"/>
+          </a:xfrm>
+          <a:prstGeom prst="ellipse">
+            <a:avLst/>
+          </a:prstGeom>
+          <a:solidFill>
+            <a:srgbClr val="00A0B0"/>
+          </a:solidFill>
+          <a:ln>
+            <a:noFill/>
+          </a:ln>
+        </p:spPr>
+        <p:style>
+          <a:lnRef idx="1">
+            <a:schemeClr val="accent1"/>
+          </a:lnRef>
+          <a:fillRef idx="3">
+            <a:schemeClr val="accent1"/>
+          </a:fillRef>
+          <a:effectRef idx="2">
+            <a:schemeClr val="accent1"/>
+          </a:effectRef>
+          <a:fontRef idx="minor">
+            <a:schemeClr val="lt1"/>
+          </a:fontRef>
+        </p:style>
+        <p:txBody>
+          <a:bodyPr rtlCol="0" anchor="ctr"/>
+          <a:lstStyle/>
+          <a:p>
+            <a:pPr algn="ctr"/>
+          </a:p>
+        </p:txBody>
+      </p:sp>
+      <p:sp>
+        <p:nvSpPr>
+          <p:cNvPr id="17" name="TextBox 16"/>
+          <p:cNvSpPr txBox="1"/>
+          <p:nvPr/>
+        </p:nvSpPr>
+        <p:spPr>
+          <a:xfrm>
+            <a:off x="914400" y="4183380"/>
+            <a:ext cx="777240" cy="777240"/>
+          </a:xfrm>
+          <a:prstGeom prst="rect">
+            <a:avLst/>
+          </a:prstGeom>
+          <a:noFill/>
+        </p:spPr>
+        <p:txBody>
+          <a:bodyPr wrap="square" lIns="45720" rIns="45720" tIns="18288" bIns="18288" anchor="ctr">
+            <a:spAutoFit/>
+          </a:bodyPr>
+          <a:lstStyle/>
+          <a:p>
+            <a:pPr algn="ctr"/>
+            <a:r>
+              <a:rPr sz="2800" b="1" i="0">
+                <a:solidFill>
+                  <a:srgbClr val="FFFFFF"/>
+                </a:solidFill>
+                <a:latin typeface="Calibri"/>
+              </a:rPr>
+              <a:t>4</a:t>
+            </a:r>
+          </a:p>
+        </p:txBody>
+      </p:sp>
+      <p:sp>
+        <p:nvSpPr>
+          <p:cNvPr id="18" name="Rounded Rectangle 17"/>
+          <p:cNvSpPr/>
+          <p:nvPr/>
+        </p:nvSpPr>
+        <p:spPr>
+          <a:xfrm>
+            <a:off x="2011680" y="4183380"/>
+            <a:ext cx="9144000" cy="777240"/>
+          </a:xfrm>
+          <a:prstGeom prst="roundRect">
+            <a:avLst>
+              <a:gd name="adj" fmla="val 8000"/>
+            </a:avLst>
+          </a:prstGeom>
+          <a:solidFill>
+            <a:srgbClr val="FBFBFD"/>
+          </a:solidFill>
+          <a:ln w="19050">
+            <a:solidFill>
+              <a:srgbClr val="00A0B0"/>
+            </a:solidFill>
+          </a:ln>
+        </p:spPr>
+        <p:style>
+          <a:lnRef idx="1">
+            <a:schemeClr val="accent1"/>
+          </a:lnRef>
+          <a:fillRef idx="3">
+            <a:schemeClr val="accent1"/>
+          </a:fillRef>
+          <a:effectRef idx="2">
+            <a:schemeClr val="accent1"/>
+          </a:effectRef>
+          <a:fontRef idx="minor">
+            <a:schemeClr val="lt1"/>
+          </a:fontRef>
+        </p:style>
+        <p:txBody>
+          <a:bodyPr rtlCol="0" anchor="ctr"/>
+          <a:lstStyle/>
+          <a:p>
+            <a:pPr algn="ctr"/>
+          </a:p>
+        </p:txBody>
+      </p:sp>
+      <p:sp>
+        <p:nvSpPr>
+          <p:cNvPr id="19" name="TextBox 18"/>
+          <p:cNvSpPr txBox="1"/>
+          <p:nvPr/>
+        </p:nvSpPr>
+        <p:spPr>
+          <a:xfrm>
+            <a:off x="2286000" y="4183380"/>
+            <a:ext cx="8686800" cy="777240"/>
+          </a:xfrm>
+          <a:prstGeom prst="rect">
+            <a:avLst/>
+          </a:prstGeom>
+          <a:noFill/>
+        </p:spPr>
+        <p:txBody>
+          <a:bodyPr wrap="square" lIns="45720" rIns="45720" tIns="18288" bIns="18288" anchor="ctr">
+            <a:spAutoFit/>
+          </a:bodyPr>
+          <a:lstStyle/>
+          <a:p>
+            <a:pPr algn="l"/>
+            <a:r>
+              <a:rPr sz="1800" b="0" i="0">
+                <a:solidFill>
+                  <a:srgbClr val="1A1A2E"/>
+                </a:solidFill>
+                <a:latin typeface="Calibri"/>
+              </a:rPr>
+              <a:t>Prompt specifici = codice più sicuro per default</a:t>
+            </a:r>
+          </a:p>
+        </p:txBody>
+      </p:sp>
+      <p:sp>
+        <p:nvSpPr>
+          <p:cNvPr id="20" name="Oval 19"/>
+          <p:cNvSpPr/>
+          <p:nvPr/>
+        </p:nvSpPr>
+        <p:spPr>
+          <a:xfrm>
+            <a:off x="914400" y="5097780"/>
+            <a:ext cx="777240" cy="777240"/>
+          </a:xfrm>
+          <a:prstGeom prst="ellipse">
+            <a:avLst/>
+          </a:prstGeom>
+          <a:solidFill>
+            <a:srgbClr val="00A0B0"/>
+          </a:solidFill>
+          <a:ln>
+            <a:noFill/>
+          </a:ln>
+        </p:spPr>
+        <p:style>
+          <a:lnRef idx="1">
+            <a:schemeClr val="accent1"/>
+          </a:lnRef>
+          <a:fillRef idx="3">
+            <a:schemeClr val="accent1"/>
+          </a:fillRef>
+          <a:effectRef idx="2">
+            <a:schemeClr val="accent1"/>
+          </a:effectRef>
+          <a:fontRef idx="minor">
+            <a:schemeClr val="lt1"/>
+          </a:fontRef>
+        </p:style>
+        <p:txBody>
+          <a:bodyPr rtlCol="0" anchor="ctr"/>
+          <a:lstStyle/>
+          <a:p>
+            <a:pPr algn="ctr"/>
+          </a:p>
+        </p:txBody>
+      </p:sp>
+      <p:sp>
+        <p:nvSpPr>
+          <p:cNvPr id="21" name="TextBox 20"/>
+          <p:cNvSpPr txBox="1"/>
+          <p:nvPr/>
+        </p:nvSpPr>
+        <p:spPr>
+          <a:xfrm>
+            <a:off x="914400" y="5097780"/>
+            <a:ext cx="777240" cy="777240"/>
+          </a:xfrm>
+          <a:prstGeom prst="rect">
+            <a:avLst/>
+          </a:prstGeom>
+          <a:noFill/>
+        </p:spPr>
+        <p:txBody>
+          <a:bodyPr wrap="square" lIns="45720" rIns="45720" tIns="18288" bIns="18288" anchor="ctr">
+            <a:spAutoFit/>
+          </a:bodyPr>
+          <a:lstStyle/>
+          <a:p>
+            <a:pPr algn="ctr"/>
+            <a:r>
+              <a:rPr sz="2800" b="1" i="0">
+                <a:solidFill>
+                  <a:srgbClr val="FFFFFF"/>
+                </a:solidFill>
+                <a:latin typeface="Calibri"/>
+              </a:rPr>
+              <a:t>5</a:t>
+            </a:r>
+          </a:p>
+        </p:txBody>
+      </p:sp>
+      <p:sp>
+        <p:nvSpPr>
+          <p:cNvPr id="22" name="Rounded Rectangle 21"/>
+          <p:cNvSpPr/>
+          <p:nvPr/>
+        </p:nvSpPr>
+        <p:spPr>
+          <a:xfrm>
+            <a:off x="2011680" y="5097780"/>
+            <a:ext cx="9144000" cy="777240"/>
+          </a:xfrm>
+          <a:prstGeom prst="roundRect">
+            <a:avLst>
+              <a:gd name="adj" fmla="val 8000"/>
+            </a:avLst>
+          </a:prstGeom>
+          <a:solidFill>
+            <a:srgbClr val="FBFBFD"/>
+          </a:solidFill>
+          <a:ln w="19050">
+            <a:solidFill>
+              <a:srgbClr val="00A0B0"/>
+            </a:solidFill>
+          </a:ln>
+        </p:spPr>
+        <p:style>
+          <a:lnRef idx="1">
+            <a:schemeClr val="accent1"/>
+          </a:lnRef>
+          <a:fillRef idx="3">
+            <a:schemeClr val="accent1"/>
+          </a:fillRef>
+          <a:effectRef idx="2">
+            <a:schemeClr val="accent1"/>
+          </a:effectRef>
+          <a:fontRef idx="minor">
+            <a:schemeClr val="lt1"/>
+          </a:fontRef>
+        </p:style>
+        <p:txBody>
+          <a:bodyPr rtlCol="0" anchor="ctr"/>
+          <a:lstStyle/>
+          <a:p>
+            <a:pPr algn="ctr"/>
+          </a:p>
+        </p:txBody>
+      </p:sp>
+      <p:sp>
+        <p:nvSpPr>
+          <p:cNvPr id="23" name="TextBox 22"/>
+          <p:cNvSpPr txBox="1"/>
+          <p:nvPr/>
+        </p:nvSpPr>
+        <p:spPr>
+          <a:xfrm>
+            <a:off x="2286000" y="5097780"/>
+            <a:ext cx="8686800" cy="777240"/>
+          </a:xfrm>
+          <a:prstGeom prst="rect">
+            <a:avLst/>
+          </a:prstGeom>
+          <a:noFill/>
+        </p:spPr>
+        <p:txBody>
+          <a:bodyPr wrap="square" lIns="45720" rIns="45720" tIns="18288" bIns="18288" anchor="ctr">
+            <a:spAutoFit/>
+          </a:bodyPr>
+          <a:lstStyle/>
+          <a:p>
+            <a:pPr algn="l"/>
+            <a:r>
+              <a:rPr sz="1800" b="0" i="0">
+                <a:solidFill>
+                  <a:srgbClr val="1A1A2E"/>
+                </a:solidFill>
+                <a:latin typeface="Calibri"/>
+              </a:rPr>
+              <a:t>EU AI Act dal 2026: documentazione + supervisione umana</a:t>
+            </a:r>
+          </a:p>
+        </p:txBody>
+      </p:sp>
+      <p:cxnSp>
+        <p:nvCxnSpPr>
+          <p:cNvPr id="24" name="Connector 23"/>
+          <p:cNvCxnSpPr/>
+          <p:nvPr/>
+        </p:nvCxnSpPr>
+        <p:spPr>
+          <a:xfrm>
+            <a:off x="457200" y="6446520"/>
+            <a:ext cx="11274552" cy="0"/>
+          </a:xfrm>
+          <a:prstGeom prst="line">
+            <a:avLst/>
+          </a:prstGeom>
+          <a:ln w="19050">
+            <a:solidFill>
+              <a:srgbClr val="00A0B0"/>
+            </a:solidFill>
+          </a:ln>
+        </p:spPr>
+        <p:style>
+          <a:lnRef idx="2">
+            <a:schemeClr val="accent1"/>
+          </a:lnRef>
+          <a:fillRef idx="0">
+            <a:schemeClr val="accent1"/>
+          </a:fillRef>
+          <a:effectRef idx="1">
+            <a:schemeClr val="accent1"/>
+          </a:effectRef>
+          <a:fontRef idx="minor">
+            <a:schemeClr val="tx1"/>
+          </a:fontRef>
+        </p:style>
+      </p:cxnSp>
+      <p:sp>
+        <p:nvSpPr>
+          <p:cNvPr id="25" name="TextBox 24"/>
+          <p:cNvSpPr txBox="1"/>
+          <p:nvPr/>
+        </p:nvSpPr>
+        <p:spPr>
+          <a:xfrm>
+            <a:off x="457200" y="6473952"/>
+            <a:ext cx="7315200" cy="292608"/>
+          </a:xfrm>
+          <a:prstGeom prst="rect">
+            <a:avLst/>
+          </a:prstGeom>
+          <a:noFill/>
+        </p:spPr>
+        <p:txBody>
+          <a:bodyPr wrap="square" lIns="45720" rIns="45720" tIns="18288" bIns="18288" anchor="t">
+            <a:spAutoFit/>
+          </a:bodyPr>
+          <a:lstStyle/>
+          <a:p>
+            <a:pPr algn="l"/>
+            <a:r>
+              <a:rPr sz="1000" b="0" i="0">
+                <a:solidFill>
+                  <a:srgbClr val="6B7280"/>
+                </a:solidFill>
+                <a:latin typeface="Calibri"/>
+              </a:rPr>
+              <a:t>Secure Coding · Corso IFTS STEM · A. Manneschi · 2024/2025</a:t>
+            </a:r>
+          </a:p>
+        </p:txBody>
+      </p:sp>
+      <p:sp>
+        <p:nvSpPr>
+          <p:cNvPr id="26" name="TextBox 25"/>
+          <p:cNvSpPr txBox="1"/>
+          <p:nvPr/>
+        </p:nvSpPr>
+        <p:spPr>
+          <a:xfrm>
+            <a:off x="10515600" y="6473952"/>
+            <a:ext cx="1188720" cy="292608"/>
+          </a:xfrm>
+          <a:prstGeom prst="rect">
+            <a:avLst/>
+          </a:prstGeom>
+          <a:noFill/>
+        </p:spPr>
+        <p:txBody>
+          <a:bodyPr wrap="square" lIns="45720" rIns="45720" tIns="18288" bIns="18288" anchor="t">
+            <a:spAutoFit/>
+          </a:bodyPr>
+          <a:lstStyle/>
+          <a:p>
+            <a:pPr algn="r"/>
+            <a:r>
+              <a:rPr sz="1000" b="1" i="0">
+                <a:solidFill>
+                  <a:srgbClr val="6B7280"/>
+                </a:solidFill>
+                <a:latin typeface="Calibri"/>
+              </a:rPr>
+              <a:t>L7  ·  14/16</a:t>
+            </a:r>
+          </a:p>
+        </p:txBody>
+      </p:sp>
+    </p:spTree>
+  </p:cSld>
+  <p:clrMapOvr>
+    <a:masterClrMapping/>
+  </p:clrMapOvr>
+</p:sld>
+</file>
+
+<file path=ppt/slides/slide15.xml><?xml version="1.0" encoding="utf-8"?>
+<p:sld xmlns:a="http://schemas.openxmlformats.org/drawingml/2006/main" xmlns:p="http://schemas.openxmlformats.org/presentationml/2006/main" xmlns:r="http://schemas.openxmlformats.org/officeDocument/2006/relationships">
+  <p:cSld>
+    <p:spTree>
+      <p:nvGrpSpPr>
+        <p:cNvPr id="1" name=""/>
+        <p:cNvGrpSpPr/>
+        <p:nvPr/>
+      </p:nvGrpSpPr>
+      <p:grpSpPr/>
+      <p:sp>
+        <p:nvSpPr>
+          <p:cNvPr id="2" name="Rectangle 1"/>
+          <p:cNvSpPr/>
+          <p:nvPr/>
+        </p:nvSpPr>
+        <p:spPr>
+          <a:xfrm>
+            <a:off x="0" y="0"/>
+            <a:ext cx="4114800" cy="6858000"/>
           </a:xfrm>
           <a:prstGeom prst="rect">
             <a:avLst/>
@@ -6043,6 +7365,398 @@
       </p:sp>
       <p:sp>
         <p:nvSpPr>
+          <p:cNvPr id="3" name="Rectangle 2"/>
+          <p:cNvSpPr/>
+          <p:nvPr/>
+        </p:nvSpPr>
+        <p:spPr>
+          <a:xfrm>
+            <a:off x="4114800" y="0"/>
+            <a:ext cx="8046720" cy="6858000"/>
+          </a:xfrm>
+          <a:prstGeom prst="rect">
+            <a:avLst/>
+          </a:prstGeom>
+          <a:solidFill>
+            <a:srgbClr val="F1F4F8"/>
+          </a:solidFill>
+          <a:ln>
+            <a:noFill/>
+          </a:ln>
+        </p:spPr>
+        <p:style>
+          <a:lnRef idx="1">
+            <a:schemeClr val="accent1"/>
+          </a:lnRef>
+          <a:fillRef idx="3">
+            <a:schemeClr val="accent1"/>
+          </a:fillRef>
+          <a:effectRef idx="2">
+            <a:schemeClr val="accent1"/>
+          </a:effectRef>
+          <a:fontRef idx="minor">
+            <a:schemeClr val="lt1"/>
+          </a:fontRef>
+        </p:style>
+        <p:txBody>
+          <a:bodyPr rtlCol="0" anchor="ctr"/>
+          <a:lstStyle/>
+          <a:p>
+            <a:pPr algn="ctr"/>
+          </a:p>
+        </p:txBody>
+      </p:sp>
+      <p:sp>
+        <p:nvSpPr>
+          <p:cNvPr id="4" name="Rectangle 3"/>
+          <p:cNvSpPr/>
+          <p:nvPr/>
+        </p:nvSpPr>
+        <p:spPr>
+          <a:xfrm>
+            <a:off x="4114800" y="0"/>
+            <a:ext cx="137160" cy="6858000"/>
+          </a:xfrm>
+          <a:prstGeom prst="rect">
+            <a:avLst/>
+          </a:prstGeom>
+          <a:solidFill>
+            <a:srgbClr val="00A0B0"/>
+          </a:solidFill>
+          <a:ln>
+            <a:noFill/>
+          </a:ln>
+        </p:spPr>
+        <p:style>
+          <a:lnRef idx="1">
+            <a:schemeClr val="accent1"/>
+          </a:lnRef>
+          <a:fillRef idx="3">
+            <a:schemeClr val="accent1"/>
+          </a:fillRef>
+          <a:effectRef idx="2">
+            <a:schemeClr val="accent1"/>
+          </a:effectRef>
+          <a:fontRef idx="minor">
+            <a:schemeClr val="lt1"/>
+          </a:fontRef>
+        </p:style>
+        <p:txBody>
+          <a:bodyPr rtlCol="0" anchor="ctr"/>
+          <a:lstStyle/>
+          <a:p>
+            <a:pPr algn="ctr"/>
+          </a:p>
+        </p:txBody>
+      </p:sp>
+      <p:sp>
+        <p:nvSpPr>
+          <p:cNvPr id="5" name="TextBox 4"/>
+          <p:cNvSpPr txBox="1"/>
+          <p:nvPr/>
+        </p:nvSpPr>
+        <p:spPr>
+          <a:xfrm>
+            <a:off x="274320" y="2103120"/>
+            <a:ext cx="3657600" cy="2286000"/>
+          </a:xfrm>
+          <a:prstGeom prst="rect">
+            <a:avLst/>
+          </a:prstGeom>
+          <a:noFill/>
+        </p:spPr>
+        <p:txBody>
+          <a:bodyPr wrap="square" lIns="45720" rIns="45720" tIns="18288" bIns="18288" anchor="t">
+            <a:spAutoFit/>
+          </a:bodyPr>
+          <a:lstStyle/>
+          <a:p>
+            <a:pPr algn="ctr"/>
+            <a:r>
+              <a:rPr sz="17000" b="1" i="0">
+                <a:solidFill>
+                  <a:srgbClr val="00A0B0"/>
+                </a:solidFill>
+                <a:latin typeface="Calibri"/>
+              </a:rPr>
+              <a:t>03</a:t>
+            </a:r>
+          </a:p>
+        </p:txBody>
+      </p:sp>
+      <p:sp>
+        <p:nvSpPr>
+          <p:cNvPr id="6" name="TextBox 5"/>
+          <p:cNvSpPr txBox="1"/>
+          <p:nvPr/>
+        </p:nvSpPr>
+        <p:spPr>
+          <a:xfrm>
+            <a:off x="274320" y="4572000"/>
+            <a:ext cx="3657600" cy="457200"/>
+          </a:xfrm>
+          <a:prstGeom prst="rect">
+            <a:avLst/>
+          </a:prstGeom>
+          <a:noFill/>
+        </p:spPr>
+        <p:txBody>
+          <a:bodyPr wrap="square" lIns="45720" rIns="45720" tIns="18288" bIns="18288" anchor="t">
+            <a:spAutoFit/>
+          </a:bodyPr>
+          <a:lstStyle/>
+          <a:p>
+            <a:pPr algn="ctr"/>
+            <a:r>
+              <a:rPr sz="2000" b="1" i="0">
+                <a:solidFill>
+                  <a:srgbClr val="6FD8E0"/>
+                </a:solidFill>
+                <a:latin typeface="Calibri"/>
+              </a:rPr>
+              <a:t>PARTE</a:t>
+            </a:r>
+          </a:p>
+        </p:txBody>
+      </p:sp>
+      <p:sp>
+        <p:nvSpPr>
+          <p:cNvPr id="7" name="TextBox 6"/>
+          <p:cNvSpPr txBox="1"/>
+          <p:nvPr/>
+        </p:nvSpPr>
+        <p:spPr>
+          <a:xfrm>
+            <a:off x="4572000" y="2286000"/>
+            <a:ext cx="7315200" cy="1645920"/>
+          </a:xfrm>
+          <a:prstGeom prst="rect">
+            <a:avLst/>
+          </a:prstGeom>
+          <a:noFill/>
+        </p:spPr>
+        <p:txBody>
+          <a:bodyPr wrap="square" lIns="45720" rIns="45720" tIns="18288" bIns="18288" anchor="t">
+            <a:spAutoFit/>
+          </a:bodyPr>
+          <a:lstStyle/>
+          <a:p>
+            <a:pPr algn="l"/>
+            <a:r>
+              <a:rPr sz="4400" b="1" i="0">
+                <a:solidFill>
+                  <a:srgbClr val="0F2D52"/>
+                </a:solidFill>
+                <a:latin typeface="Calibri"/>
+              </a:rPr>
+              <a:t>Lab in aula</a:t>
+            </a:r>
+          </a:p>
+        </p:txBody>
+      </p:sp>
+      <p:sp>
+        <p:nvSpPr>
+          <p:cNvPr id="8" name="TextBox 7"/>
+          <p:cNvSpPr txBox="1"/>
+          <p:nvPr/>
+        </p:nvSpPr>
+        <p:spPr>
+          <a:xfrm>
+            <a:off x="4572000" y="3931920"/>
+            <a:ext cx="7315200" cy="1828800"/>
+          </a:xfrm>
+          <a:prstGeom prst="rect">
+            <a:avLst/>
+          </a:prstGeom>
+          <a:noFill/>
+        </p:spPr>
+        <p:txBody>
+          <a:bodyPr wrap="square" lIns="45720" rIns="45720" tIns="18288" bIns="18288" anchor="t">
+            <a:spAutoFit/>
+          </a:bodyPr>
+          <a:lstStyle/>
+          <a:p>
+            <a:pPr algn="l"/>
+            <a:r>
+              <a:rPr sz="1800" b="0" i="1">
+                <a:solidFill>
+                  <a:srgbClr val="6B7280"/>
+                </a:solidFill>
+                <a:latin typeface="Calibri"/>
+              </a:rPr>
+              <a:t>Validation collettiva di codice AI vulnerabile</a:t>
+            </a:r>
+          </a:p>
+        </p:txBody>
+      </p:sp>
+      <p:cxnSp>
+        <p:nvCxnSpPr>
+          <p:cNvPr id="9" name="Connector 8"/>
+          <p:cNvCxnSpPr/>
+          <p:nvPr/>
+        </p:nvCxnSpPr>
+        <p:spPr>
+          <a:xfrm>
+            <a:off x="457200" y="6446520"/>
+            <a:ext cx="11274552" cy="0"/>
+          </a:xfrm>
+          <a:prstGeom prst="line">
+            <a:avLst/>
+          </a:prstGeom>
+          <a:ln w="19050">
+            <a:solidFill>
+              <a:srgbClr val="00A0B0"/>
+            </a:solidFill>
+          </a:ln>
+        </p:spPr>
+        <p:style>
+          <a:lnRef idx="2">
+            <a:schemeClr val="accent1"/>
+          </a:lnRef>
+          <a:fillRef idx="0">
+            <a:schemeClr val="accent1"/>
+          </a:fillRef>
+          <a:effectRef idx="1">
+            <a:schemeClr val="accent1"/>
+          </a:effectRef>
+          <a:fontRef idx="minor">
+            <a:schemeClr val="tx1"/>
+          </a:fontRef>
+        </p:style>
+      </p:cxnSp>
+      <p:sp>
+        <p:nvSpPr>
+          <p:cNvPr id="10" name="TextBox 9"/>
+          <p:cNvSpPr txBox="1"/>
+          <p:nvPr/>
+        </p:nvSpPr>
+        <p:spPr>
+          <a:xfrm>
+            <a:off x="457200" y="6473952"/>
+            <a:ext cx="7315200" cy="292608"/>
+          </a:xfrm>
+          <a:prstGeom prst="rect">
+            <a:avLst/>
+          </a:prstGeom>
+          <a:noFill/>
+        </p:spPr>
+        <p:txBody>
+          <a:bodyPr wrap="square" lIns="45720" rIns="45720" tIns="18288" bIns="18288" anchor="t">
+            <a:spAutoFit/>
+          </a:bodyPr>
+          <a:lstStyle/>
+          <a:p>
+            <a:pPr algn="l"/>
+            <a:r>
+              <a:rPr sz="1000" b="0" i="0">
+                <a:solidFill>
+                  <a:srgbClr val="6B7280"/>
+                </a:solidFill>
+                <a:latin typeface="Calibri"/>
+              </a:rPr>
+              <a:t>Secure Coding · Corso IFTS STEM · A. Manneschi · 2024/2025</a:t>
+            </a:r>
+          </a:p>
+        </p:txBody>
+      </p:sp>
+      <p:sp>
+        <p:nvSpPr>
+          <p:cNvPr id="11" name="TextBox 10"/>
+          <p:cNvSpPr txBox="1"/>
+          <p:nvPr/>
+        </p:nvSpPr>
+        <p:spPr>
+          <a:xfrm>
+            <a:off x="10515600" y="6473952"/>
+            <a:ext cx="1188720" cy="292608"/>
+          </a:xfrm>
+          <a:prstGeom prst="rect">
+            <a:avLst/>
+          </a:prstGeom>
+          <a:noFill/>
+        </p:spPr>
+        <p:txBody>
+          <a:bodyPr wrap="square" lIns="45720" rIns="45720" tIns="18288" bIns="18288" anchor="t">
+            <a:spAutoFit/>
+          </a:bodyPr>
+          <a:lstStyle/>
+          <a:p>
+            <a:pPr algn="r"/>
+            <a:r>
+              <a:rPr sz="1000" b="1" i="0">
+                <a:solidFill>
+                  <a:srgbClr val="6B7280"/>
+                </a:solidFill>
+                <a:latin typeface="Calibri"/>
+              </a:rPr>
+              <a:t>L7  ·  15/16</a:t>
+            </a:r>
+          </a:p>
+        </p:txBody>
+      </p:sp>
+    </p:spTree>
+  </p:cSld>
+  <p:clrMapOvr>
+    <a:masterClrMapping/>
+  </p:clrMapOvr>
+</p:sld>
+</file>
+
+<file path=ppt/slides/slide16.xml><?xml version="1.0" encoding="utf-8"?>
+<p:sld xmlns:a="http://schemas.openxmlformats.org/drawingml/2006/main" xmlns:p="http://schemas.openxmlformats.org/presentationml/2006/main" xmlns:r="http://schemas.openxmlformats.org/officeDocument/2006/relationships">
+  <p:cSld>
+    <p:spTree>
+      <p:nvGrpSpPr>
+        <p:cNvPr id="1" name=""/>
+        <p:cNvGrpSpPr/>
+        <p:nvPr/>
+      </p:nvGrpSpPr>
+      <p:grpSpPr/>
+      <p:sp>
+        <p:nvSpPr>
+          <p:cNvPr id="2" name="Rectangle 1"/>
+          <p:cNvSpPr/>
+          <p:nvPr/>
+        </p:nvSpPr>
+        <p:spPr>
+          <a:xfrm>
+            <a:off x="0" y="0"/>
+            <a:ext cx="12191695" cy="6858000"/>
+          </a:xfrm>
+          <a:prstGeom prst="rect">
+            <a:avLst/>
+          </a:prstGeom>
+          <a:solidFill>
+            <a:srgbClr val="081B33"/>
+          </a:solidFill>
+          <a:ln>
+            <a:noFill/>
+          </a:ln>
+        </p:spPr>
+        <p:style>
+          <a:lnRef idx="1">
+            <a:schemeClr val="accent1"/>
+          </a:lnRef>
+          <a:fillRef idx="3">
+            <a:schemeClr val="accent1"/>
+          </a:fillRef>
+          <a:effectRef idx="2">
+            <a:schemeClr val="accent1"/>
+          </a:effectRef>
+          <a:fontRef idx="minor">
+            <a:schemeClr val="lt1"/>
+          </a:fontRef>
+        </p:style>
+        <p:txBody>
+          <a:bodyPr rtlCol="0" anchor="ctr"/>
+          <a:lstStyle/>
+          <a:p>
+            <a:pPr algn="ctr"/>
+          </a:p>
+        </p:txBody>
+      </p:sp>
+      <p:sp>
+        <p:nvSpPr>
           <p:cNvPr id="3" name="Oval 2"/>
           <p:cNvSpPr/>
           <p:nvPr/>
@@ -6455,7 +8169,7 @@
                 </a:solidFill>
                 <a:latin typeface="Calibri"/>
               </a:rPr>
-              <a:t>L7  ·  14/14</a:t>
+              <a:t>L7  ·  16/16</a:t>
             </a:r>
           </a:p>
         </p:txBody>
@@ -7291,7 +9005,7 @@
                 </a:solidFill>
                 <a:latin typeface="Calibri"/>
               </a:rPr>
-              <a:t>L7  ·  2/14</a:t>
+              <a:t>L7  ·  2/16</a:t>
             </a:r>
           </a:p>
         </p:txBody>
@@ -7683,7 +9397,7 @@
                 </a:solidFill>
                 <a:latin typeface="Calibri"/>
               </a:rPr>
-              <a:t>L7  ·  3/14</a:t>
+              <a:t>L7  ·  3/16</a:t>
             </a:r>
           </a:p>
         </p:txBody>
@@ -8159,7 +9873,7 @@
                 </a:solidFill>
                 <a:latin typeface="Calibri"/>
               </a:rPr>
-              <a:t>L7  ·  4/14</a:t>
+              <a:t>L7  ·  4/16</a:t>
             </a:r>
           </a:p>
         </p:txBody>
@@ -8848,7 +10562,7 @@
                 </a:solidFill>
                 <a:latin typeface="Calibri"/>
               </a:rPr>
-              <a:t>L7  ·  5/14</a:t>
+              <a:t>L7  ·  5/16</a:t>
             </a:r>
           </a:p>
         </p:txBody>
@@ -9240,7 +10954,7 @@
                 </a:solidFill>
                 <a:latin typeface="Calibri"/>
               </a:rPr>
-              <a:t>L7  ·  6/14</a:t>
+              <a:t>L7  ·  6/16</a:t>
             </a:r>
           </a:p>
         </p:txBody>
@@ -9554,7 +11268,7 @@
                 </a:solidFill>
                 <a:latin typeface="Calibri"/>
               </a:rPr>
-              <a:t>L7  ·  7/14</a:t>
+              <a:t>L7  ·  7/16</a:t>
             </a:r>
           </a:p>
         </p:txBody>
@@ -10030,7 +11744,7 @@
                 </a:solidFill>
                 <a:latin typeface="Calibri"/>
               </a:rPr>
-              <a:t>L7  ·  8/14</a:t>
+              <a:t>L7  ·  8/16</a:t>
             </a:r>
           </a:p>
         </p:txBody>
@@ -10805,7 +12519,7 @@
                 </a:solidFill>
                 <a:latin typeface="Calibri"/>
               </a:rPr>
-              <a:t>L7  ·  9/14</a:t>
+              <a:t>L7  ·  9/16</a:t>
             </a:r>
           </a:p>
         </p:txBody>

</xml_diff>